<commit_message>
ImmersIA slide: architecture diagram with actors and flows, chevron roadmap
Co-Authored-By: Claude Fable 5.1 <noreply@anthropic.com>
Claude-Session: https://claude.ai/code/session_017Xxdh6Fcf9L1mCznqCimm2
</commit_message>
<xml_diff>
--- a/presentations/ImmersIA_commission_pedagogique.pptx
+++ b/presentations/ImmersIA_commission_pedagogique.pptx
@@ -502,7 +502,7 @@
           <a:p>
             <a:r>
               <a:rPr lang="en-US" dirty="0"/>
-              <a:t>ImmersIA en une slide. Gauche : le problème (machines hétérogènes, TP perdus en installation) et deux chiffres qui apparaissent au clic. Droite : la solution en trois briques, la feuille de route jusqu'au déploiement, les cibles du MVP.</a:t>
+              <a:t>ImmersIA en une slide. Gauche : le problème et deux chiffres (apparaissent au clic). Droite : architecture (apprenti → connexion → environnement prêt → tuteur IA, boucle de feedback ; traces → notre LLM → vue enseignant), feuille de route en chevrons, cibles du MVP.</a:t>
             </a:r>
             <a:endParaRPr lang="en-US" dirty="0"/>
           </a:p>
@@ -884,7 +884,7 @@
         <p:spPr>
           <a:xfrm>
             <a:off x="0" y="0"/>
-            <a:ext cx="3931920" cy="6858000"/>
+            <a:ext cx="3566160" cy="6858000"/>
           </a:xfrm>
           <a:prstGeom prst="rect">
             <a:avLst/>
@@ -908,7 +908,7 @@
         </p:nvSpPr>
         <p:spPr>
           <a:xfrm flipV="1">
-            <a:off x="3922776" y="0"/>
+            <a:off x="3557016" y="0"/>
             <a:ext cx="731520" cy="6858000"/>
           </a:xfrm>
           <a:prstGeom prst="rtTriangle">
@@ -991,7 +991,7 @@
         </p:blipFill>
         <p:spPr>
           <a:xfrm>
-            <a:off x="457200" y="347472"/>
+            <a:off x="411480" y="347472"/>
             <a:ext cx="1371600" cy="585216"/>
           </a:xfrm>
           <a:prstGeom prst="rect">
@@ -1007,8 +1007,8 @@
         </p:nvSpPr>
         <p:spPr>
           <a:xfrm>
-            <a:off x="457200" y="1188720"/>
-            <a:ext cx="3154680" cy="640080"/>
+            <a:off x="411480" y="1143000"/>
+            <a:ext cx="2971800" cy="640080"/>
           </a:xfrm>
           <a:prstGeom prst="rect">
             <a:avLst/>
@@ -1024,6 +1024,201 @@
               <a:buNone/>
             </a:pPr>
             <a:r>
+              <a:rPr lang="en-US" sz="3600" b="1" dirty="0">
+                <a:solidFill>
+                  <a:srgbClr val="FFFFFF"/>
+                </a:solidFill>
+                <a:latin typeface="Montserrat" pitchFamily="34" charset="0"/>
+                <a:ea typeface="Montserrat" pitchFamily="34" charset="-122"/>
+                <a:cs typeface="Montserrat" pitchFamily="34" charset="-120"/>
+              </a:rPr>
+              <a:t>ImmersIA</a:t>
+            </a:r>
+            <a:endParaRPr lang="en-US" sz="3600" dirty="0"/>
+          </a:p>
+        </p:txBody>
+      </p:sp>
+      <p:sp>
+        <p:nvSpPr>
+          <p:cNvPr id="8" name="Accroche"/>
+          <p:cNvSpPr txBox="1"/>
+          <p:nvPr/>
+        </p:nvSpPr>
+        <p:spPr>
+          <a:xfrm>
+            <a:off x="411480" y="1801368"/>
+            <a:ext cx="2971800" cy="685800"/>
+          </a:xfrm>
+          <a:prstGeom prst="rect">
+            <a:avLst/>
+          </a:prstGeom>
+          <a:noFill/>
+          <a:ln/>
+        </p:spPr>
+        <p:txBody>
+          <a:bodyPr wrap="square" lIns="0" tIns="0" rIns="0" bIns="0" rtlCol="0" anchor="t"/>
+          <a:lstStyle/>
+          <a:p>
+            <a:pPr indent="0" marL="0">
+              <a:buNone/>
+            </a:pPr>
+            <a:r>
+              <a:rPr lang="en-US" sz="1100" dirty="0">
+                <a:solidFill>
+                  <a:srgbClr val="FFFFFF"/>
+                </a:solidFill>
+                <a:latin typeface="Montserrat" pitchFamily="34" charset="0"/>
+                <a:ea typeface="Montserrat" pitchFamily="34" charset="-122"/>
+                <a:cs typeface="Montserrat" pitchFamily="34" charset="-120"/>
+              </a:rPr>
+              <a:t>Le lab virtuel des apprentis Data &amp; IA : cas réels, environnement prêt, tuteur IA.</a:t>
+            </a:r>
+            <a:endParaRPr lang="en-US" sz="1100" dirty="0"/>
+          </a:p>
+        </p:txBody>
+      </p:sp>
+      <p:sp>
+        <p:nvSpPr>
+          <p:cNvPr id="9" name="Problème"/>
+          <p:cNvSpPr txBox="1"/>
+          <p:nvPr/>
+        </p:nvSpPr>
+        <p:spPr>
+          <a:xfrm>
+            <a:off x="411480" y="2606040"/>
+            <a:ext cx="2971800" cy="914400"/>
+          </a:xfrm>
+          <a:prstGeom prst="rect">
+            <a:avLst/>
+          </a:prstGeom>
+          <a:noFill/>
+          <a:ln/>
+        </p:spPr>
+        <p:txBody>
+          <a:bodyPr wrap="square" lIns="0" tIns="0" rIns="0" bIns="0" rtlCol="0" anchor="t"/>
+          <a:lstStyle/>
+          <a:p>
+            <a:pPr indent="0" marL="0">
+              <a:buNone/>
+            </a:pPr>
+            <a:r>
+              <a:rPr lang="en-US" sz="1000" dirty="0">
+                <a:solidFill>
+                  <a:srgbClr val="FFFFFF"/>
+                </a:solidFill>
+                <a:latin typeface="Montserrat" pitchFamily="34" charset="0"/>
+                <a:ea typeface="Montserrat" pitchFamily="34" charset="-122"/>
+                <a:cs typeface="Montserrat" pitchFamily="34" charset="-120"/>
+              </a:rPr>
+              <a:t>Chaque étudiant arrive avec sa machine : les premiers TP se perdent à installer outils et packages, et l'enseignant dépanne au lieu d'enseigner.</a:t>
+            </a:r>
+            <a:endParaRPr lang="en-US" sz="1000" dirty="0"/>
+          </a:p>
+        </p:txBody>
+      </p:sp>
+      <p:sp>
+        <p:nvSpPr>
+          <p:cNvPr id="10" name="Stat 1 chiffre"/>
+          <p:cNvSpPr txBox="1"/>
+          <p:nvPr/>
+        </p:nvSpPr>
+        <p:spPr>
+          <a:xfrm>
+            <a:off x="411480" y="3611880"/>
+            <a:ext cx="2971800" cy="457200"/>
+          </a:xfrm>
+          <a:prstGeom prst="rect">
+            <a:avLst/>
+          </a:prstGeom>
+          <a:noFill/>
+          <a:ln/>
+        </p:spPr>
+        <p:txBody>
+          <a:bodyPr wrap="square" lIns="0" tIns="0" rIns="0" bIns="0" rtlCol="0" anchor="ctr"/>
+          <a:lstStyle/>
+          <a:p>
+            <a:pPr indent="0" marL="0">
+              <a:buNone/>
+            </a:pPr>
+            <a:r>
+              <a:rPr lang="en-US" sz="3000" b="1" dirty="0">
+                <a:solidFill>
+                  <a:srgbClr val="FFFFFF"/>
+                </a:solidFill>
+                <a:latin typeface="Montserrat" pitchFamily="34" charset="0"/>
+                <a:ea typeface="Montserrat" pitchFamily="34" charset="-122"/>
+                <a:cs typeface="Montserrat" pitchFamily="34" charset="-120"/>
+              </a:rPr>
+              <a:t>30 à 60 min</a:t>
+            </a:r>
+            <a:endParaRPr lang="en-US" sz="3000" dirty="0"/>
+          </a:p>
+        </p:txBody>
+      </p:sp>
+      <p:sp>
+        <p:nvSpPr>
+          <p:cNvPr id="11" name="Stat 1 légende"/>
+          <p:cNvSpPr txBox="1"/>
+          <p:nvPr/>
+        </p:nvSpPr>
+        <p:spPr>
+          <a:xfrm>
+            <a:off x="411480" y="4087368"/>
+            <a:ext cx="2971800" cy="274320"/>
+          </a:xfrm>
+          <a:prstGeom prst="rect">
+            <a:avLst/>
+          </a:prstGeom>
+          <a:noFill/>
+          <a:ln/>
+        </p:spPr>
+        <p:txBody>
+          <a:bodyPr wrap="square" lIns="0" tIns="0" rIns="0" bIns="0" rtlCol="0" anchor="t"/>
+          <a:lstStyle/>
+          <a:p>
+            <a:pPr indent="0" marL="0">
+              <a:buNone/>
+            </a:pPr>
+            <a:r>
+              <a:rPr lang="en-US" sz="900" dirty="0">
+                <a:solidFill>
+                  <a:srgbClr val="FFFFFF"/>
+                </a:solidFill>
+                <a:latin typeface="Montserrat" pitchFamily="34" charset="0"/>
+                <a:ea typeface="Montserrat" pitchFamily="34" charset="-122"/>
+                <a:cs typeface="Montserrat" pitchFamily="34" charset="-120"/>
+              </a:rPr>
+              <a:t>de chaque première séance passées à installer</a:t>
+            </a:r>
+            <a:endParaRPr lang="en-US" sz="900" dirty="0"/>
+          </a:p>
+        </p:txBody>
+      </p:sp>
+      <p:sp>
+        <p:nvSpPr>
+          <p:cNvPr id="12" name="Stat 2 chiffre"/>
+          <p:cNvSpPr txBox="1"/>
+          <p:nvPr/>
+        </p:nvSpPr>
+        <p:spPr>
+          <a:xfrm>
+            <a:off x="411480" y="4434840"/>
+            <a:ext cx="2971800" cy="548640"/>
+          </a:xfrm>
+          <a:prstGeom prst="rect">
+            <a:avLst/>
+          </a:prstGeom>
+          <a:noFill/>
+          <a:ln/>
+        </p:spPr>
+        <p:txBody>
+          <a:bodyPr wrap="square" lIns="0" tIns="0" rIns="0" bIns="0" rtlCol="0" anchor="ctr"/>
+          <a:lstStyle/>
+          <a:p>
+            <a:pPr indent="0" marL="0">
+              <a:buNone/>
+            </a:pPr>
+            <a:r>
               <a:rPr lang="en-US" sz="3800" b="1" dirty="0">
                 <a:solidFill>
                   <a:srgbClr val="FFFFFF"/>
@@ -1032,7 +1227,7 @@
                 <a:ea typeface="Montserrat" pitchFamily="34" charset="-122"/>
                 <a:cs typeface="Montserrat" pitchFamily="34" charset="-120"/>
               </a:rPr>
-              <a:t>ImmersIA</a:t>
+              <a:t>78 %</a:t>
             </a:r>
             <a:endParaRPr lang="en-US" sz="3800" dirty="0"/>
           </a:p>
@@ -1040,14 +1235,14 @@
       </p:sp>
       <p:sp>
         <p:nvSpPr>
-          <p:cNvPr id="8" name="Accroche"/>
-          <p:cNvSpPr txBox="1"/>
-          <p:nvPr/>
-        </p:nvSpPr>
-        <p:spPr>
-          <a:xfrm>
-            <a:off x="457200" y="1847088"/>
-            <a:ext cx="3154680" cy="640080"/>
+          <p:cNvPr id="13" name="Stat 2 légende"/>
+          <p:cNvSpPr txBox="1"/>
+          <p:nvPr/>
+        </p:nvSpPr>
+        <p:spPr>
+          <a:xfrm>
+            <a:off x="411480" y="5001768"/>
+            <a:ext cx="2971800" cy="411480"/>
           </a:xfrm>
           <a:prstGeom prst="rect">
             <a:avLst/>
@@ -1063,7 +1258,7 @@
               <a:buNone/>
             </a:pPr>
             <a:r>
-              <a:rPr lang="en-US" sz="1150" dirty="0">
+              <a:rPr lang="en-US" sz="900" dirty="0">
                 <a:solidFill>
                   <a:srgbClr val="FFFFFF"/>
                 </a:solidFill>
@@ -1071,204 +1266,9 @@
                 <a:ea typeface="Montserrat" pitchFamily="34" charset="-122"/>
                 <a:cs typeface="Montserrat" pitchFamily="34" charset="-120"/>
               </a:rPr>
-              <a:t>Le lab virtuel des apprentis Data &amp; IA : des cas métiers réels, un environnement prêt, un tuteur IA.</a:t>
-            </a:r>
-            <a:endParaRPr lang="en-US" sz="1150" dirty="0"/>
-          </a:p>
-        </p:txBody>
-      </p:sp>
-      <p:sp>
-        <p:nvSpPr>
-          <p:cNvPr id="9" name="Problème"/>
-          <p:cNvSpPr txBox="1"/>
-          <p:nvPr/>
-        </p:nvSpPr>
-        <p:spPr>
-          <a:xfrm>
-            <a:off x="457200" y="2606040"/>
-            <a:ext cx="3154680" cy="822960"/>
-          </a:xfrm>
-          <a:prstGeom prst="rect">
-            <a:avLst/>
-          </a:prstGeom>
-          <a:noFill/>
-          <a:ln/>
-        </p:spPr>
-        <p:txBody>
-          <a:bodyPr wrap="square" lIns="0" tIns="0" rIns="0" bIns="0" rtlCol="0" anchor="t"/>
-          <a:lstStyle/>
-          <a:p>
-            <a:pPr indent="0" marL="0">
-              <a:buNone/>
-            </a:pPr>
-            <a:r>
-              <a:rPr lang="en-US" sz="1050" dirty="0">
-                <a:solidFill>
-                  <a:srgbClr val="FFFFFF"/>
-                </a:solidFill>
-                <a:latin typeface="Montserrat" pitchFamily="34" charset="0"/>
-                <a:ea typeface="Montserrat" pitchFamily="34" charset="-122"/>
-                <a:cs typeface="Montserrat" pitchFamily="34" charset="-120"/>
-              </a:rPr>
-              <a:t>Chaque étudiant arrive avec sa machine : les premiers TP se perdent à installer outils et packages, et l'enseignant dépanne au lieu d'enseigner.</a:t>
-            </a:r>
-            <a:endParaRPr lang="en-US" sz="1050" dirty="0"/>
-          </a:p>
-        </p:txBody>
-      </p:sp>
-      <p:sp>
-        <p:nvSpPr>
-          <p:cNvPr id="10" name="Stat 1 chiffre"/>
-          <p:cNvSpPr txBox="1"/>
-          <p:nvPr/>
-        </p:nvSpPr>
-        <p:spPr>
-          <a:xfrm>
-            <a:off x="457200" y="3520440"/>
-            <a:ext cx="3154680" cy="502920"/>
-          </a:xfrm>
-          <a:prstGeom prst="rect">
-            <a:avLst/>
-          </a:prstGeom>
-          <a:noFill/>
-          <a:ln/>
-        </p:spPr>
-        <p:txBody>
-          <a:bodyPr wrap="square" lIns="0" tIns="0" rIns="0" bIns="0" rtlCol="0" anchor="ctr"/>
-          <a:lstStyle/>
-          <a:p>
-            <a:pPr indent="0" marL="0">
-              <a:buNone/>
-            </a:pPr>
-            <a:r>
-              <a:rPr lang="en-US" sz="3200" b="1" dirty="0">
-                <a:solidFill>
-                  <a:srgbClr val="FFFFFF"/>
-                </a:solidFill>
-                <a:latin typeface="Montserrat" pitchFamily="34" charset="0"/>
-                <a:ea typeface="Montserrat" pitchFamily="34" charset="-122"/>
-                <a:cs typeface="Montserrat" pitchFamily="34" charset="-120"/>
-              </a:rPr>
-              <a:t>30 à 60 min</a:t>
-            </a:r>
-            <a:endParaRPr lang="en-US" sz="3200" dirty="0"/>
-          </a:p>
-        </p:txBody>
-      </p:sp>
-      <p:sp>
-        <p:nvSpPr>
-          <p:cNvPr id="11" name="Stat 1 légende"/>
-          <p:cNvSpPr txBox="1"/>
-          <p:nvPr/>
-        </p:nvSpPr>
-        <p:spPr>
-          <a:xfrm>
-            <a:off x="457200" y="4041648"/>
-            <a:ext cx="3154680" cy="274320"/>
-          </a:xfrm>
-          <a:prstGeom prst="rect">
-            <a:avLst/>
-          </a:prstGeom>
-          <a:noFill/>
-          <a:ln/>
-        </p:spPr>
-        <p:txBody>
-          <a:bodyPr wrap="square" lIns="0" tIns="0" rIns="0" bIns="0" rtlCol="0" anchor="t"/>
-          <a:lstStyle/>
-          <a:p>
-            <a:pPr indent="0" marL="0">
-              <a:buNone/>
-            </a:pPr>
-            <a:r>
-              <a:rPr lang="en-US" sz="950" dirty="0">
-                <a:solidFill>
-                  <a:srgbClr val="FFFFFF"/>
-                </a:solidFill>
-                <a:latin typeface="Montserrat" pitchFamily="34" charset="0"/>
-                <a:ea typeface="Montserrat" pitchFamily="34" charset="-122"/>
-                <a:cs typeface="Montserrat" pitchFamily="34" charset="-120"/>
-              </a:rPr>
-              <a:t>de chaque première séance passées à installer</a:t>
-            </a:r>
-            <a:endParaRPr lang="en-US" sz="950" dirty="0"/>
-          </a:p>
-        </p:txBody>
-      </p:sp>
-      <p:sp>
-        <p:nvSpPr>
-          <p:cNvPr id="12" name="Stat 2 chiffre"/>
-          <p:cNvSpPr txBox="1"/>
-          <p:nvPr/>
-        </p:nvSpPr>
-        <p:spPr>
-          <a:xfrm>
-            <a:off x="457200" y="4434840"/>
-            <a:ext cx="3154680" cy="548640"/>
-          </a:xfrm>
-          <a:prstGeom prst="rect">
-            <a:avLst/>
-          </a:prstGeom>
-          <a:noFill/>
-          <a:ln/>
-        </p:spPr>
-        <p:txBody>
-          <a:bodyPr wrap="square" lIns="0" tIns="0" rIns="0" bIns="0" rtlCol="0" anchor="ctr"/>
-          <a:lstStyle/>
-          <a:p>
-            <a:pPr indent="0" marL="0">
-              <a:buNone/>
-            </a:pPr>
-            <a:r>
-              <a:rPr lang="en-US" sz="4000" b="1" dirty="0">
-                <a:solidFill>
-                  <a:srgbClr val="FFFFFF"/>
-                </a:solidFill>
-                <a:latin typeface="Montserrat" pitchFamily="34" charset="0"/>
-                <a:ea typeface="Montserrat" pitchFamily="34" charset="-122"/>
-                <a:cs typeface="Montserrat" pitchFamily="34" charset="-120"/>
-              </a:rPr>
-              <a:t>78 %</a:t>
-            </a:r>
-            <a:endParaRPr lang="en-US" sz="4000" dirty="0"/>
-          </a:p>
-        </p:txBody>
-      </p:sp>
-      <p:sp>
-        <p:nvSpPr>
-          <p:cNvPr id="13" name="Stat 2 légende"/>
-          <p:cNvSpPr txBox="1"/>
-          <p:nvPr/>
-        </p:nvSpPr>
-        <p:spPr>
-          <a:xfrm>
-            <a:off x="457200" y="5001768"/>
-            <a:ext cx="3154680" cy="411480"/>
-          </a:xfrm>
-          <a:prstGeom prst="rect">
-            <a:avLst/>
-          </a:prstGeom>
-          <a:noFill/>
-          <a:ln/>
-        </p:spPr>
-        <p:txBody>
-          <a:bodyPr wrap="square" lIns="0" tIns="0" rIns="0" bIns="0" rtlCol="0" anchor="t"/>
-          <a:lstStyle/>
-          <a:p>
-            <a:pPr indent="0" marL="0">
-              <a:buNone/>
-            </a:pPr>
-            <a:r>
-              <a:rPr lang="en-US" sz="950" dirty="0">
-                <a:solidFill>
-                  <a:srgbClr val="FFFFFF"/>
-                </a:solidFill>
-                <a:latin typeface="Montserrat" pitchFamily="34" charset="0"/>
-                <a:ea typeface="Montserrat" pitchFamily="34" charset="-122"/>
-                <a:cs typeface="Montserrat" pitchFamily="34" charset="-120"/>
-              </a:rPr>
               <a:t>des étudiants citent matériel et configuration comme première source de frustration en TP</a:t>
             </a:r>
-            <a:endParaRPr lang="en-US" sz="950" dirty="0"/>
+            <a:endParaRPr lang="en-US" sz="900" dirty="0"/>
           </a:p>
         </p:txBody>
       </p:sp>
@@ -1288,8 +1288,8 @@
         </p:blipFill>
         <p:spPr>
           <a:xfrm>
-            <a:off x="457200" y="5806440"/>
-            <a:ext cx="1234440" cy="740664"/>
+            <a:off x="411480" y="5806440"/>
+            <a:ext cx="1188720" cy="713232"/>
           </a:xfrm>
           <a:prstGeom prst="rect">
             <a:avLst/>
@@ -1304,8 +1304,8 @@
         </p:nvSpPr>
         <p:spPr>
           <a:xfrm>
-            <a:off x="1828800" y="5870448"/>
-            <a:ext cx="2011680" cy="640080"/>
+            <a:off x="1737360" y="5852160"/>
+            <a:ext cx="1691640" cy="640080"/>
           </a:xfrm>
           <a:prstGeom prst="rect">
             <a:avLst/>
@@ -1321,7 +1321,7 @@
               <a:buNone/>
             </a:pPr>
             <a:r>
-              <a:rPr lang="en-US" sz="850" dirty="0">
+              <a:rPr lang="en-US" sz="800" dirty="0">
                 <a:solidFill>
                   <a:srgbClr val="FFFFFF"/>
                 </a:solidFill>
@@ -1329,54 +1329,37 @@
                 <a:ea typeface="Montserrat" pitchFamily="34" charset="-122"/>
                 <a:cs typeface="Montserrat" pitchFamily="34" charset="-120"/>
               </a:rPr>
-              <a:t>Projet PST&amp;B, lauréat OPCO Atlas,</a:t>
-            </a:r>
-            <a:endParaRPr lang="en-US" sz="850" dirty="0"/>
-          </a:p>
+              <a:t>Projet PST&amp;B, lauréat OPCO Atlas, développé avec Galileo.</a:t>
+            </a:r>
+            <a:endParaRPr lang="en-US" sz="800" dirty="0"/>
+          </a:p>
+        </p:txBody>
+      </p:sp>
+      <p:sp>
+        <p:nvSpPr>
+          <p:cNvPr id="16" name="Label architecture"/>
+          <p:cNvSpPr txBox="1"/>
+          <p:nvPr/>
+        </p:nvSpPr>
+        <p:spPr>
+          <a:xfrm>
+            <a:off x="4617720" y="237744"/>
+            <a:ext cx="2743200" cy="219456"/>
+          </a:xfrm>
+          <a:prstGeom prst="rect">
+            <a:avLst/>
+          </a:prstGeom>
+          <a:noFill/>
+          <a:ln/>
+        </p:spPr>
+        <p:txBody>
+          <a:bodyPr wrap="square" lIns="0" tIns="0" rIns="0" bIns="0" rtlCol="0" anchor="ctr"/>
+          <a:lstStyle/>
           <a:p>
             <a:pPr indent="0" marL="0">
               <a:buNone/>
             </a:pPr>
             <a:r>
-              <a:rPr lang="en-US" sz="850" dirty="0">
-                <a:solidFill>
-                  <a:srgbClr val="FFFFFF"/>
-                </a:solidFill>
-                <a:latin typeface="Montserrat" pitchFamily="34" charset="0"/>
-                <a:ea typeface="Montserrat" pitchFamily="34" charset="-122"/>
-                <a:cs typeface="Montserrat" pitchFamily="34" charset="-120"/>
-              </a:rPr>
-              <a:t>développé avec Galileo.</a:t>
-            </a:r>
-            <a:endParaRPr lang="en-US" sz="850" dirty="0"/>
-          </a:p>
-        </p:txBody>
-      </p:sp>
-      <p:sp>
-        <p:nvSpPr>
-          <p:cNvPr id="16" name="Label solution"/>
-          <p:cNvSpPr txBox="1"/>
-          <p:nvPr/>
-        </p:nvSpPr>
-        <p:spPr>
-          <a:xfrm>
-            <a:off x="5074920" y="384048"/>
-            <a:ext cx="6720840" cy="237744"/>
-          </a:xfrm>
-          <a:prstGeom prst="rect">
-            <a:avLst/>
-          </a:prstGeom>
-          <a:noFill/>
-          <a:ln/>
-        </p:spPr>
-        <p:txBody>
-          <a:bodyPr wrap="square" lIns="0" tIns="0" rIns="0" bIns="0" rtlCol="0" anchor="ctr"/>
-          <a:lstStyle/>
-          <a:p>
-            <a:pPr indent="0" marL="0">
-              <a:buNone/>
-            </a:pPr>
-            <a:r>
               <a:rPr lang="en-US" sz="900" b="1" spc="250" kern="0" dirty="0">
                 <a:solidFill>
                   <a:srgbClr val="01A6E0"/>
@@ -1385,7 +1368,7 @@
                 <a:ea typeface="Montserrat" pitchFamily="34" charset="-122"/>
                 <a:cs typeface="Montserrat" pitchFamily="34" charset="-120"/>
               </a:rPr>
-              <a:t>LA SOLUTION</a:t>
+              <a:t>ARCHITECTURE</a:t>
             </a:r>
             <a:endParaRPr lang="en-US" sz="900" dirty="0"/>
           </a:p>
@@ -1393,24 +1376,24 @@
       </p:sp>
       <p:sp>
         <p:nvSpPr>
-          <p:cNvPr id="17" name="Cercle Accès"/>
+          <p:cNvPr id="17" name="Acteur Apprenti"/>
           <p:cNvSpPr/>
           <p:nvPr/>
         </p:nvSpPr>
         <p:spPr>
           <a:xfrm>
-            <a:off x="5074920" y="749808"/>
-            <a:ext cx="457200" cy="457200"/>
+            <a:off x="4645152" y="1005840"/>
+            <a:ext cx="548640" cy="548640"/>
           </a:xfrm>
           <a:prstGeom prst="ellipse">
             <a:avLst/>
           </a:prstGeom>
           <a:solidFill>
-            <a:srgbClr val="01A6E0"/>
+            <a:srgbClr val="152539"/>
           </a:solidFill>
           <a:ln w="12700">
             <a:solidFill>
-              <a:srgbClr val="01A6E0"/>
+              <a:srgbClr val="152539"/>
             </a:solidFill>
             <a:prstDash val="solid"/>
           </a:ln>
@@ -1418,7 +1401,7 @@
       </p:sp>
       <p:pic>
         <p:nvPicPr>
-          <p:cNvPr id="18" name="Icône Accès" descr="preencoded.png">    </p:cNvPr>
+          <p:cNvPr id="18" name="Icône Apprenti" descr="preencoded.png">    </p:cNvPr>
           <p:cNvPicPr>
             <a:picLocks noChangeAspect="1"/>
           </p:cNvPicPr>
@@ -1432,8 +1415,8 @@
         </p:blipFill>
         <p:spPr>
           <a:xfrm>
-            <a:off x="5175504" y="850392"/>
-            <a:ext cx="256032" cy="256032"/>
+            <a:off x="4773168" y="1133856"/>
+            <a:ext cx="292608" cy="292608"/>
           </a:xfrm>
           <a:prstGeom prst="rect">
             <a:avLst/>
@@ -1442,30 +1425,30 @@
       </p:pic>
       <p:sp>
         <p:nvSpPr>
-          <p:cNvPr id="19" name="Titre Accès"/>
-          <p:cNvSpPr txBox="1"/>
-          <p:nvPr/>
-        </p:nvSpPr>
-        <p:spPr>
-          <a:xfrm>
-            <a:off x="5074920" y="1316736"/>
-            <a:ext cx="2057400" cy="310896"/>
-          </a:xfrm>
-          <a:prstGeom prst="rect">
-            <a:avLst/>
-          </a:prstGeom>
-          <a:noFill/>
-          <a:ln/>
-        </p:spPr>
-        <p:txBody>
-          <a:bodyPr wrap="square" lIns="0" tIns="0" rIns="0" bIns="0" rtlCol="0" anchor="ctr"/>
-          <a:lstStyle/>
-          <a:p>
-            <a:pPr indent="0" marL="0">
-              <a:buNone/>
-            </a:pPr>
-            <a:r>
-              <a:rPr lang="en-US" sz="1300" b="1" dirty="0">
+          <p:cNvPr id="19" name="Nom Apprenti"/>
+          <p:cNvSpPr txBox="1"/>
+          <p:nvPr/>
+        </p:nvSpPr>
+        <p:spPr>
+          <a:xfrm>
+            <a:off x="4416552" y="1591056"/>
+            <a:ext cx="1005840" cy="219456"/>
+          </a:xfrm>
+          <a:prstGeom prst="rect">
+            <a:avLst/>
+          </a:prstGeom>
+          <a:noFill/>
+          <a:ln/>
+        </p:spPr>
+        <p:txBody>
+          <a:bodyPr wrap="square" lIns="0" tIns="0" rIns="0" bIns="0" rtlCol="0" anchor="t"/>
+          <a:lstStyle/>
+          <a:p>
+            <a:pPr algn="ctr" indent="0" marL="0">
+              <a:buNone/>
+            </a:pPr>
+            <a:r>
+              <a:rPr lang="en-US" sz="850" b="1" dirty="0">
                 <a:solidFill>
                   <a:srgbClr val="152539"/>
                 </a:solidFill>
@@ -1473,61 +1456,73 @@
                 <a:ea typeface="Montserrat" pitchFamily="34" charset="-122"/>
                 <a:cs typeface="Montserrat" pitchFamily="34" charset="-120"/>
               </a:rPr>
-              <a:t>Accès</a:t>
-            </a:r>
-            <a:endParaRPr lang="en-US" sz="1300" dirty="0"/>
-          </a:p>
-        </p:txBody>
-      </p:sp>
-      <p:sp>
-        <p:nvSpPr>
-          <p:cNvPr id="20" name="Texte Accès"/>
-          <p:cNvSpPr txBox="1"/>
-          <p:nvPr/>
-        </p:nvSpPr>
-        <p:spPr>
-          <a:xfrm>
-            <a:off x="5074920" y="1645920"/>
-            <a:ext cx="2057400" cy="1097280"/>
-          </a:xfrm>
-          <a:prstGeom prst="rect">
-            <a:avLst/>
-          </a:prstGeom>
-          <a:noFill/>
-          <a:ln/>
-        </p:spPr>
-        <p:txBody>
-          <a:bodyPr wrap="square" lIns="0" tIns="0" rIns="0" bIns="0" rtlCol="0" anchor="t"/>
-          <a:lstStyle/>
-          <a:p>
-            <a:pPr indent="0" marL="0">
-              <a:buNone/>
-            </a:pPr>
-            <a:r>
-              <a:rPr lang="en-US" sz="1000" dirty="0">
-                <a:solidFill>
-                  <a:srgbClr val="475569"/>
-                </a:solidFill>
-                <a:latin typeface="Montserrat" pitchFamily="34" charset="0"/>
-                <a:ea typeface="Montserrat" pitchFamily="34" charset="-122"/>
-                <a:cs typeface="Montserrat" pitchFamily="34" charset="-120"/>
-              </a:rPr>
-              <a:t>Connexion avec le compte étudiant. L'environnement est prêt, en classe ou à distance.</a:t>
-            </a:r>
-            <a:endParaRPr lang="en-US" sz="1000" dirty="0"/>
-          </a:p>
-        </p:txBody>
-      </p:sp>
-      <p:sp>
-        <p:nvSpPr>
-          <p:cNvPr id="21" name="Cercle Scénarios &amp; labs"/>
+              <a:t>Apprenti</a:t>
+            </a:r>
+            <a:endParaRPr lang="en-US" sz="850" dirty="0"/>
+          </a:p>
+        </p:txBody>
+      </p:sp>
+      <p:sp>
+        <p:nvSpPr>
+          <p:cNvPr id="20" name="Flèche apprenti → connexion"/>
           <p:cNvSpPr/>
           <p:nvPr/>
         </p:nvSpPr>
         <p:spPr>
           <a:xfrm>
-            <a:off x="7406640" y="749808"/>
-            <a:ext cx="457200" cy="457200"/>
+            <a:off x="5230368" y="1280160"/>
+            <a:ext cx="228600" cy="0"/>
+          </a:xfrm>
+          <a:prstGeom prst="line">
+            <a:avLst/>
+          </a:prstGeom>
+          <a:noFill/>
+          <a:ln w="19050">
+            <a:solidFill>
+              <a:srgbClr val="01A6E0"/>
+            </a:solidFill>
+            <a:prstDash val="solid"/>
+            <a:tailEnd type="triangle"/>
+          </a:ln>
+        </p:spPr>
+      </p:sp>
+      <p:sp>
+        <p:nvSpPr>
+          <p:cNvPr id="21" name="Brique Connexion"/>
+          <p:cNvSpPr/>
+          <p:nvPr/>
+        </p:nvSpPr>
+        <p:spPr>
+          <a:xfrm>
+            <a:off x="5486400" y="868680"/>
+            <a:ext cx="1371600" cy="868680"/>
+          </a:xfrm>
+          <a:prstGeom prst="roundRect">
+            <a:avLst>
+              <a:gd name="adj" fmla="val 6316"/>
+            </a:avLst>
+          </a:prstGeom>
+          <a:solidFill>
+            <a:srgbClr val="FFFFFF"/>
+          </a:solidFill>
+          <a:ln w="15875">
+            <a:solidFill>
+              <a:srgbClr val="01A6E0"/>
+            </a:solidFill>
+            <a:prstDash val="solid"/>
+          </a:ln>
+        </p:spPr>
+      </p:sp>
+      <p:sp>
+        <p:nvSpPr>
+          <p:cNvPr id="22" name="Pastille Connexion"/>
+          <p:cNvSpPr/>
+          <p:nvPr/>
+        </p:nvSpPr>
+        <p:spPr>
+          <a:xfrm>
+            <a:off x="5577840" y="960120"/>
+            <a:ext cx="329184" cy="329184"/>
           </a:xfrm>
           <a:prstGeom prst="ellipse">
             <a:avLst/>
@@ -1545,7 +1540,7 @@
       </p:sp>
       <p:pic>
         <p:nvPicPr>
-          <p:cNvPr id="22" name="Icône Scénarios &amp; labs" descr="preencoded.png">    </p:cNvPr>
+          <p:cNvPr id="23" name="Icône Connexion" descr="preencoded.png">    </p:cNvPr>
           <p:cNvPicPr>
             <a:picLocks noChangeAspect="1"/>
           </p:cNvPicPr>
@@ -1559,8 +1554,8 @@
         </p:blipFill>
         <p:spPr>
           <a:xfrm>
-            <a:off x="7507224" y="850392"/>
-            <a:ext cx="256032" cy="256032"/>
+            <a:off x="5650992" y="1033272"/>
+            <a:ext cx="182880" cy="182880"/>
           </a:xfrm>
           <a:prstGeom prst="rect">
             <a:avLst/>
@@ -1569,14 +1564,14 @@
       </p:pic>
       <p:sp>
         <p:nvSpPr>
-          <p:cNvPr id="23" name="Titre Scénarios &amp;amp; labs"/>
-          <p:cNvSpPr txBox="1"/>
-          <p:nvPr/>
-        </p:nvSpPr>
-        <p:spPr>
-          <a:xfrm>
-            <a:off x="7406640" y="1316736"/>
-            <a:ext cx="2057400" cy="310896"/>
+          <p:cNvPr id="24" name="Titre Connexion"/>
+          <p:cNvSpPr txBox="1"/>
+          <p:nvPr/>
+        </p:nvSpPr>
+        <p:spPr>
+          <a:xfrm>
+            <a:off x="5961888" y="941832"/>
+            <a:ext cx="841248" cy="365760"/>
           </a:xfrm>
           <a:prstGeom prst="rect">
             <a:avLst/>
@@ -1592,7 +1587,7 @@
               <a:buNone/>
             </a:pPr>
             <a:r>
-              <a:rPr lang="en-US" sz="1300" b="1" dirty="0">
+              <a:rPr lang="en-US" sz="950" b="1" dirty="0">
                 <a:solidFill>
                   <a:srgbClr val="152539"/>
                 </a:solidFill>
@@ -1600,22 +1595,22 @@
                 <a:ea typeface="Montserrat" pitchFamily="34" charset="-122"/>
                 <a:cs typeface="Montserrat" pitchFamily="34" charset="-120"/>
               </a:rPr>
-              <a:t>Scénarios &amp; labs</a:t>
-            </a:r>
-            <a:endParaRPr lang="en-US" sz="1300" dirty="0"/>
-          </a:p>
-        </p:txBody>
-      </p:sp>
-      <p:sp>
-        <p:nvSpPr>
-          <p:cNvPr id="24" name="Texte Scénarios &amp;amp; labs"/>
-          <p:cNvSpPr txBox="1"/>
-          <p:nvPr/>
-        </p:nvSpPr>
-        <p:spPr>
-          <a:xfrm>
-            <a:off x="7406640" y="1645920"/>
-            <a:ext cx="2057400" cy="1097280"/>
+              <a:t>Connexion</a:t>
+            </a:r>
+            <a:endParaRPr lang="en-US" sz="950" dirty="0"/>
+          </a:p>
+        </p:txBody>
+      </p:sp>
+      <p:sp>
+        <p:nvSpPr>
+          <p:cNvPr id="25" name="Détail Connexion"/>
+          <p:cNvSpPr txBox="1"/>
+          <p:nvPr/>
+        </p:nvSpPr>
+        <p:spPr>
+          <a:xfrm>
+            <a:off x="5577840" y="1325880"/>
+            <a:ext cx="1207008" cy="365760"/>
           </a:xfrm>
           <a:prstGeom prst="rect">
             <a:avLst/>
@@ -1631,7 +1626,7 @@
               <a:buNone/>
             </a:pPr>
             <a:r>
-              <a:rPr lang="en-US" sz="1000" dirty="0">
+              <a:rPr lang="en-US" sz="750" dirty="0">
                 <a:solidFill>
                   <a:srgbClr val="475569"/>
                 </a:solidFill>
@@ -1639,40 +1634,157 @@
                 <a:ea typeface="Montserrat" pitchFamily="34" charset="-122"/>
                 <a:cs typeface="Montserrat" pitchFamily="34" charset="-120"/>
               </a:rPr>
-              <a:t>Cas banque, assurance, conseil. Tuteur IA, VS Code, notebooks et datasets prêts, mode sans code.</a:t>
-            </a:r>
-            <a:endParaRPr lang="en-US" sz="1000" dirty="0"/>
-          </a:p>
-        </p:txBody>
-      </p:sp>
-      <p:sp>
-        <p:nvSpPr>
-          <p:cNvPr id="25" name="Cercle Vue enseignant"/>
+              <a:t>compte étudiant, accès unique</a:t>
+            </a:r>
+            <a:endParaRPr lang="en-US" sz="750" dirty="0"/>
+          </a:p>
+        </p:txBody>
+      </p:sp>
+      <p:sp>
+        <p:nvSpPr>
+          <p:cNvPr id="26" name="Flèche connexion → environnement"/>
           <p:cNvSpPr/>
           <p:nvPr/>
         </p:nvSpPr>
         <p:spPr>
           <a:xfrm>
-            <a:off x="9738360" y="749808"/>
-            <a:ext cx="457200" cy="457200"/>
-          </a:xfrm>
-          <a:prstGeom prst="ellipse">
-            <a:avLst/>
-          </a:prstGeom>
-          <a:solidFill>
-            <a:srgbClr val="01A6E0"/>
+            <a:off x="6885432" y="1280160"/>
+            <a:ext cx="173736" cy="0"/>
+          </a:xfrm>
+          <a:prstGeom prst="line">
+            <a:avLst/>
+          </a:prstGeom>
+          <a:noFill/>
+          <a:ln w="19050">
+            <a:solidFill>
+              <a:srgbClr val="01A6E0"/>
+            </a:solidFill>
+            <a:prstDash val="solid"/>
+            <a:tailEnd type="triangle"/>
+          </a:ln>
+        </p:spPr>
+      </p:sp>
+      <p:sp>
+        <p:nvSpPr>
+          <p:cNvPr id="27" name="Conteneur environnement"/>
+          <p:cNvSpPr/>
+          <p:nvPr/>
+        </p:nvSpPr>
+        <p:spPr>
+          <a:xfrm>
+            <a:off x="7086600" y="658368"/>
+            <a:ext cx="4754880" cy="1298448"/>
+          </a:xfrm>
+          <a:prstGeom prst="roundRect">
+            <a:avLst>
+              <a:gd name="adj" fmla="val 5634"/>
+            </a:avLst>
+          </a:prstGeom>
+          <a:solidFill>
+            <a:srgbClr val="EAF7FD"/>
           </a:solidFill>
           <a:ln w="12700">
             <a:solidFill>
               <a:srgbClr val="01A6E0"/>
             </a:solidFill>
+            <a:prstDash val="dash"/>
+          </a:ln>
+        </p:spPr>
+      </p:sp>
+      <p:sp>
+        <p:nvSpPr>
+          <p:cNvPr id="28" name="Titre conteneur"/>
+          <p:cNvSpPr txBox="1"/>
+          <p:nvPr/>
+        </p:nvSpPr>
+        <p:spPr>
+          <a:xfrm>
+            <a:off x="7223760" y="694944"/>
+            <a:ext cx="2743200" cy="219456"/>
+          </a:xfrm>
+          <a:prstGeom prst="rect">
+            <a:avLst/>
+          </a:prstGeom>
+          <a:noFill/>
+          <a:ln/>
+        </p:spPr>
+        <p:txBody>
+          <a:bodyPr wrap="square" lIns="0" tIns="0" rIns="0" bIns="0" rtlCol="0" anchor="ctr"/>
+          <a:lstStyle/>
+          <a:p>
+            <a:pPr indent="0" marL="0">
+              <a:buNone/>
+            </a:pPr>
+            <a:r>
+              <a:rPr lang="en-US" sz="750" b="1" spc="150" kern="0" dirty="0">
+                <a:solidFill>
+                  <a:srgbClr val="01A6E0"/>
+                </a:solidFill>
+                <a:latin typeface="Montserrat" pitchFamily="34" charset="0"/>
+                <a:ea typeface="Montserrat" pitchFamily="34" charset="-122"/>
+                <a:cs typeface="Montserrat" pitchFamily="34" charset="-120"/>
+              </a:rPr>
+              <a:t>ENVIRONNEMENT IMMERSIA</a:t>
+            </a:r>
+            <a:endParaRPr lang="en-US" sz="750" dirty="0"/>
+          </a:p>
+        </p:txBody>
+      </p:sp>
+      <p:sp>
+        <p:nvSpPr>
+          <p:cNvPr id="29" name="Brique Workspace prêt"/>
+          <p:cNvSpPr/>
+          <p:nvPr/>
+        </p:nvSpPr>
+        <p:spPr>
+          <a:xfrm>
+            <a:off x="7205472" y="960120"/>
+            <a:ext cx="1389888" cy="868680"/>
+          </a:xfrm>
+          <a:prstGeom prst="roundRect">
+            <a:avLst>
+              <a:gd name="adj" fmla="val 6316"/>
+            </a:avLst>
+          </a:prstGeom>
+          <a:solidFill>
+            <a:srgbClr val="FFFFFF"/>
+          </a:solidFill>
+          <a:ln w="15875">
+            <a:solidFill>
+              <a:srgbClr val="0078BF"/>
+            </a:solidFill>
             <a:prstDash val="solid"/>
           </a:ln>
         </p:spPr>
       </p:sp>
+      <p:sp>
+        <p:nvSpPr>
+          <p:cNvPr id="30" name="Pastille Workspace prêt"/>
+          <p:cNvSpPr/>
+          <p:nvPr/>
+        </p:nvSpPr>
+        <p:spPr>
+          <a:xfrm>
+            <a:off x="7296912" y="1051560"/>
+            <a:ext cx="329184" cy="329184"/>
+          </a:xfrm>
+          <a:prstGeom prst="ellipse">
+            <a:avLst/>
+          </a:prstGeom>
+          <a:solidFill>
+            <a:srgbClr val="0078BF"/>
+          </a:solidFill>
+          <a:ln w="12700">
+            <a:solidFill>
+              <a:srgbClr val="0078BF"/>
+            </a:solidFill>
+            <a:prstDash val="solid"/>
+          </a:ln>
+        </p:spPr>
+      </p:sp>
       <p:pic>
         <p:nvPicPr>
-          <p:cNvPr id="26" name="Icône Vue enseignant" descr="preencoded.png">    </p:cNvPr>
+          <p:cNvPr id="31" name="Icône Workspace prêt" descr="preencoded.png">    </p:cNvPr>
           <p:cNvPicPr>
             <a:picLocks noChangeAspect="1"/>
           </p:cNvPicPr>
@@ -1686,8 +1798,8 @@
         </p:blipFill>
         <p:spPr>
           <a:xfrm>
-            <a:off x="9838944" y="850392"/>
-            <a:ext cx="256032" cy="256032"/>
+            <a:off x="7370064" y="1124712"/>
+            <a:ext cx="182880" cy="182880"/>
           </a:xfrm>
           <a:prstGeom prst="rect">
             <a:avLst/>
@@ -1696,14 +1808,14 @@
       </p:pic>
       <p:sp>
         <p:nvSpPr>
-          <p:cNvPr id="27" name="Titre Vue enseignant"/>
-          <p:cNvSpPr txBox="1"/>
-          <p:nvPr/>
-        </p:nvSpPr>
-        <p:spPr>
-          <a:xfrm>
-            <a:off x="9738360" y="1316736"/>
-            <a:ext cx="2057400" cy="310896"/>
+          <p:cNvPr id="32" name="Titre Workspace prêt"/>
+          <p:cNvSpPr txBox="1"/>
+          <p:nvPr/>
+        </p:nvSpPr>
+        <p:spPr>
+          <a:xfrm>
+            <a:off x="7680960" y="1033272"/>
+            <a:ext cx="859536" cy="365760"/>
           </a:xfrm>
           <a:prstGeom prst="rect">
             <a:avLst/>
@@ -1719,7 +1831,7 @@
               <a:buNone/>
             </a:pPr>
             <a:r>
-              <a:rPr lang="en-US" sz="1300" b="1" dirty="0">
+              <a:rPr lang="en-US" sz="950" b="1" dirty="0">
                 <a:solidFill>
                   <a:srgbClr val="152539"/>
                 </a:solidFill>
@@ -1727,22 +1839,22 @@
                 <a:ea typeface="Montserrat" pitchFamily="34" charset="-122"/>
                 <a:cs typeface="Montserrat" pitchFamily="34" charset="-120"/>
               </a:rPr>
-              <a:t>Vue enseignant</a:t>
-            </a:r>
-            <a:endParaRPr lang="en-US" sz="1300" dirty="0"/>
-          </a:p>
-        </p:txBody>
-      </p:sp>
-      <p:sp>
-        <p:nvSpPr>
-          <p:cNvPr id="28" name="Texte Vue enseignant"/>
-          <p:cNvSpPr txBox="1"/>
-          <p:nvPr/>
-        </p:nvSpPr>
-        <p:spPr>
-          <a:xfrm>
-            <a:off x="9738360" y="1645920"/>
-            <a:ext cx="2057400" cy="1097280"/>
+              <a:t>Workspace prêt</a:t>
+            </a:r>
+            <a:endParaRPr lang="en-US" sz="950" dirty="0"/>
+          </a:p>
+        </p:txBody>
+      </p:sp>
+      <p:sp>
+        <p:nvSpPr>
+          <p:cNvPr id="33" name="Détail Workspace prêt"/>
+          <p:cNvSpPr txBox="1"/>
+          <p:nvPr/>
+        </p:nvSpPr>
+        <p:spPr>
+          <a:xfrm>
+            <a:off x="7296912" y="1417320"/>
+            <a:ext cx="1225296" cy="365760"/>
           </a:xfrm>
           <a:prstGeom prst="rect">
             <a:avLst/>
@@ -1758,7 +1870,7 @@
               <a:buNone/>
             </a:pPr>
             <a:r>
-              <a:rPr lang="en-US" sz="1000" dirty="0">
+              <a:rPr lang="en-US" sz="750" dirty="0">
                 <a:solidFill>
                   <a:srgbClr val="475569"/>
                 </a:solidFill>
@@ -1766,69 +1878,58 @@
                 <a:ea typeface="Montserrat" pitchFamily="34" charset="-122"/>
                 <a:cs typeface="Montserrat" pitchFamily="34" charset="-120"/>
               </a:rPr>
-              <a:t>Notre LLM résume la séance, repère les difficultés et les concepts mal maîtrisés, suit chaque version soumise.</a:t>
-            </a:r>
-            <a:endParaRPr lang="en-US" sz="1000" dirty="0"/>
-          </a:p>
-        </p:txBody>
-      </p:sp>
-      <p:sp>
-        <p:nvSpPr>
-          <p:cNvPr id="29" name="Label feuille de route"/>
-          <p:cNvSpPr txBox="1"/>
-          <p:nvPr/>
-        </p:nvSpPr>
-        <p:spPr>
-          <a:xfrm>
-            <a:off x="5074920" y="2926080"/>
-            <a:ext cx="6720840" cy="237744"/>
-          </a:xfrm>
-          <a:prstGeom prst="rect">
-            <a:avLst/>
-          </a:prstGeom>
-          <a:noFill/>
-          <a:ln/>
-        </p:spPr>
-        <p:txBody>
-          <a:bodyPr wrap="square" lIns="0" tIns="0" rIns="0" bIns="0" rtlCol="0" anchor="ctr"/>
-          <a:lstStyle/>
-          <a:p>
-            <a:pPr indent="0" marL="0">
-              <a:buNone/>
-            </a:pPr>
-            <a:r>
-              <a:rPr lang="en-US" sz="900" b="1" spc="250" kern="0" dirty="0">
-                <a:solidFill>
-                  <a:srgbClr val="01A6E0"/>
-                </a:solidFill>
-                <a:latin typeface="Montserrat" pitchFamily="34" charset="0"/>
-                <a:ea typeface="Montserrat" pitchFamily="34" charset="-122"/>
-                <a:cs typeface="Montserrat" pitchFamily="34" charset="-120"/>
-              </a:rPr>
-              <a:t>FEUILLE DE ROUTE</a:t>
-            </a:r>
-            <a:endParaRPr lang="en-US" sz="900" dirty="0"/>
-          </a:p>
-        </p:txBody>
-      </p:sp>
-      <p:sp>
-        <p:nvSpPr>
-          <p:cNvPr id="30" name="Ligne de temps"/>
+              <a:t>VS Code, notebooks, datasets, no-code</a:t>
+            </a:r>
+            <a:endParaRPr lang="en-US" sz="750" dirty="0"/>
+          </a:p>
+        </p:txBody>
+      </p:sp>
+      <p:sp>
+        <p:nvSpPr>
+          <p:cNvPr id="34" name="Flèche interne 1"/>
           <p:cNvSpPr/>
           <p:nvPr/>
         </p:nvSpPr>
         <p:spPr>
           <a:xfrm>
-            <a:off x="5257800" y="3931920"/>
-            <a:ext cx="6355080" cy="0"/>
+            <a:off x="8622792" y="1280160"/>
+            <a:ext cx="109728" cy="0"/>
           </a:xfrm>
           <a:prstGeom prst="line">
             <a:avLst/>
           </a:prstGeom>
           <a:noFill/>
-          <a:ln w="25400">
+          <a:ln w="19050">
             <a:solidFill>
-              <a:srgbClr val="D9E2EC"/>
+              <a:srgbClr val="0078BF"/>
+            </a:solidFill>
+            <a:prstDash val="solid"/>
+            <a:tailEnd type="triangle"/>
+          </a:ln>
+        </p:spPr>
+      </p:sp>
+      <p:sp>
+        <p:nvSpPr>
+          <p:cNvPr id="35" name="Brique Scénarios métiers"/>
+          <p:cNvSpPr/>
+          <p:nvPr/>
+        </p:nvSpPr>
+        <p:spPr>
+          <a:xfrm>
+            <a:off x="8759952" y="960120"/>
+            <a:ext cx="1389888" cy="868680"/>
+          </a:xfrm>
+          <a:prstGeom prst="roundRect">
+            <a:avLst>
+              <a:gd name="adj" fmla="val 6316"/>
+            </a:avLst>
+          </a:prstGeom>
+          <a:solidFill>
+            <a:srgbClr val="FFFFFF"/>
+          </a:solidFill>
+          <a:ln w="15875">
+            <a:solidFill>
+              <a:srgbClr val="0078BF"/>
             </a:solidFill>
             <a:prstDash val="solid"/>
           </a:ln>
@@ -1836,55 +1937,79 @@
       </p:sp>
       <p:sp>
         <p:nvSpPr>
-          <p:cNvPr id="31" name="Jalon 1"/>
+          <p:cNvPr id="36" name="Pastille Scénarios métiers"/>
           <p:cNvSpPr/>
           <p:nvPr/>
         </p:nvSpPr>
         <p:spPr>
           <a:xfrm>
-            <a:off x="5486400" y="3840480"/>
-            <a:ext cx="182880" cy="182880"/>
+            <a:off x="8851392" y="1051560"/>
+            <a:ext cx="329184" cy="329184"/>
           </a:xfrm>
           <a:prstGeom prst="ellipse">
             <a:avLst/>
           </a:prstGeom>
           <a:solidFill>
-            <a:srgbClr val="01A6E0"/>
-          </a:solidFill>
-          <a:ln w="19050">
+            <a:srgbClr val="0078BF"/>
+          </a:solidFill>
+          <a:ln w="12700">
             <a:solidFill>
-              <a:srgbClr val="01A6E0"/>
+              <a:srgbClr val="0078BF"/>
             </a:solidFill>
             <a:prstDash val="solid"/>
           </a:ln>
         </p:spPr>
       </p:sp>
-      <p:sp>
-        <p:nvSpPr>
-          <p:cNvPr id="32" name="Date jalon 1"/>
-          <p:cNvSpPr txBox="1"/>
-          <p:nvPr/>
-        </p:nvSpPr>
-        <p:spPr>
-          <a:xfrm>
-            <a:off x="4892040" y="3364992"/>
-            <a:ext cx="1371600" cy="274320"/>
-          </a:xfrm>
-          <a:prstGeom prst="rect">
-            <a:avLst/>
-          </a:prstGeom>
-          <a:noFill/>
-          <a:ln/>
-        </p:spPr>
-        <p:txBody>
-          <a:bodyPr wrap="square" lIns="0" tIns="0" rIns="0" bIns="0" rtlCol="0" anchor="b"/>
-          <a:lstStyle/>
-          <a:p>
-            <a:pPr algn="ctr" indent="0" marL="0">
-              <a:buNone/>
-            </a:pPr>
-            <a:r>
-              <a:rPr lang="en-US" sz="1000" b="1" dirty="0">
+      <p:pic>
+        <p:nvPicPr>
+          <p:cNvPr id="37" name="Icône Scénarios métiers" descr="preencoded.png">    </p:cNvPr>
+          <p:cNvPicPr>
+            <a:picLocks noChangeAspect="1"/>
+          </p:cNvPicPr>
+          <p:nvPr/>
+        </p:nvPicPr>
+        <p:blipFill>
+          <a:blip r:embed="rId6"/>
+          <a:stretch>
+            <a:fillRect/>
+          </a:stretch>
+        </p:blipFill>
+        <p:spPr>
+          <a:xfrm>
+            <a:off x="8924544" y="1124712"/>
+            <a:ext cx="182880" cy="182880"/>
+          </a:xfrm>
+          <a:prstGeom prst="rect">
+            <a:avLst/>
+          </a:prstGeom>
+        </p:spPr>
+      </p:pic>
+      <p:sp>
+        <p:nvSpPr>
+          <p:cNvPr id="38" name="Titre Scénarios métiers"/>
+          <p:cNvSpPr txBox="1"/>
+          <p:nvPr/>
+        </p:nvSpPr>
+        <p:spPr>
+          <a:xfrm>
+            <a:off x="9235440" y="1033272"/>
+            <a:ext cx="859536" cy="365760"/>
+          </a:xfrm>
+          <a:prstGeom prst="rect">
+            <a:avLst/>
+          </a:prstGeom>
+          <a:noFill/>
+          <a:ln/>
+        </p:spPr>
+        <p:txBody>
+          <a:bodyPr wrap="square" lIns="0" tIns="0" rIns="0" bIns="0" rtlCol="0" anchor="ctr"/>
+          <a:lstStyle/>
+          <a:p>
+            <a:pPr indent="0" marL="0">
+              <a:buNone/>
+            </a:pPr>
+            <a:r>
+              <a:rPr lang="en-US" sz="950" b="1" dirty="0">
                 <a:solidFill>
                   <a:srgbClr val="152539"/>
                 </a:solidFill>
@@ -1892,22 +2017,22 @@
                 <a:ea typeface="Montserrat" pitchFamily="34" charset="-122"/>
                 <a:cs typeface="Montserrat" pitchFamily="34" charset="-120"/>
               </a:rPr>
-              <a:t>Sept. 2026</a:t>
-            </a:r>
-            <a:endParaRPr lang="en-US" sz="1000" dirty="0"/>
-          </a:p>
-        </p:txBody>
-      </p:sp>
-      <p:sp>
-        <p:nvSpPr>
-          <p:cNvPr id="33" name="Texte jalon 1"/>
-          <p:cNvSpPr txBox="1"/>
-          <p:nvPr/>
-        </p:nvSpPr>
-        <p:spPr>
-          <a:xfrm>
-            <a:off x="4892040" y="4187952"/>
-            <a:ext cx="1371600" cy="502920"/>
+              <a:t>Scénarios métiers</a:t>
+            </a:r>
+            <a:endParaRPr lang="en-US" sz="950" dirty="0"/>
+          </a:p>
+        </p:txBody>
+      </p:sp>
+      <p:sp>
+        <p:nvSpPr>
+          <p:cNvPr id="39" name="Détail Scénarios métiers"/>
+          <p:cNvSpPr txBox="1"/>
+          <p:nvPr/>
+        </p:nvSpPr>
+        <p:spPr>
+          <a:xfrm>
+            <a:off x="8851392" y="1417320"/>
+            <a:ext cx="1225296" cy="365760"/>
           </a:xfrm>
           <a:prstGeom prst="rect">
             <a:avLst/>
@@ -1919,11 +2044,11 @@
           <a:bodyPr wrap="square" lIns="0" tIns="0" rIns="0" bIns="0" rtlCol="0" anchor="t"/>
           <a:lstStyle/>
           <a:p>
-            <a:pPr algn="ctr" indent="0" marL="0">
-              <a:buNone/>
-            </a:pPr>
-            <a:r>
-              <a:rPr lang="en-US" sz="850" dirty="0">
+            <a:pPr indent="0" marL="0">
+              <a:buNone/>
+            </a:pPr>
+            <a:r>
+              <a:rPr lang="en-US" sz="750" dirty="0">
                 <a:solidFill>
                   <a:srgbClr val="475569"/>
                 </a:solidFill>
@@ -1931,22 +2056,73 @@
                 <a:ea typeface="Montserrat" pitchFamily="34" charset="-122"/>
                 <a:cs typeface="Montserrat" pitchFamily="34" charset="-120"/>
               </a:rPr>
-              <a:t>Kick-off, deux scénarios choisis</a:t>
-            </a:r>
-            <a:endParaRPr lang="en-US" sz="850" dirty="0"/>
-          </a:p>
-        </p:txBody>
-      </p:sp>
-      <p:sp>
-        <p:nvSpPr>
-          <p:cNvPr id="34" name="Jalon 2"/>
+              <a:t>banque, assurance, conseil</a:t>
+            </a:r>
+            <a:endParaRPr lang="en-US" sz="750" dirty="0"/>
+          </a:p>
+        </p:txBody>
+      </p:sp>
+      <p:sp>
+        <p:nvSpPr>
+          <p:cNvPr id="40" name="Flèche interne 2"/>
           <p:cNvSpPr/>
           <p:nvPr/>
         </p:nvSpPr>
         <p:spPr>
           <a:xfrm>
-            <a:off x="6869430" y="3794760"/>
-            <a:ext cx="274320" cy="274320"/>
+            <a:off x="10177272" y="1280160"/>
+            <a:ext cx="109728" cy="0"/>
+          </a:xfrm>
+          <a:prstGeom prst="line">
+            <a:avLst/>
+          </a:prstGeom>
+          <a:noFill/>
+          <a:ln w="19050">
+            <a:solidFill>
+              <a:srgbClr val="0078BF"/>
+            </a:solidFill>
+            <a:prstDash val="solid"/>
+            <a:tailEnd type="triangle"/>
+          </a:ln>
+        </p:spPr>
+      </p:sp>
+      <p:sp>
+        <p:nvSpPr>
+          <p:cNvPr id="41" name="Brique Tuteur IA"/>
+          <p:cNvSpPr/>
+          <p:nvPr/>
+        </p:nvSpPr>
+        <p:spPr>
+          <a:xfrm>
+            <a:off x="10314432" y="960120"/>
+            <a:ext cx="1389888" cy="868680"/>
+          </a:xfrm>
+          <a:prstGeom prst="roundRect">
+            <a:avLst>
+              <a:gd name="adj" fmla="val 6316"/>
+            </a:avLst>
+          </a:prstGeom>
+          <a:solidFill>
+            <a:srgbClr val="FFFFFF"/>
+          </a:solidFill>
+          <a:ln w="15875">
+            <a:solidFill>
+              <a:srgbClr val="BC1A49"/>
+            </a:solidFill>
+            <a:prstDash val="solid"/>
+          </a:ln>
+        </p:spPr>
+      </p:sp>
+      <p:sp>
+        <p:nvSpPr>
+          <p:cNvPr id="42" name="Pastille Tuteur IA"/>
+          <p:cNvSpPr/>
+          <p:nvPr/>
+        </p:nvSpPr>
+        <p:spPr>
+          <a:xfrm>
+            <a:off x="10405872" y="1051560"/>
+            <a:ext cx="329184" cy="329184"/>
           </a:xfrm>
           <a:prstGeom prst="ellipse">
             <a:avLst/>
@@ -1954,6 +2130,131 @@
           <a:solidFill>
             <a:srgbClr val="BC1A49"/>
           </a:solidFill>
+          <a:ln w="12700">
+            <a:solidFill>
+              <a:srgbClr val="BC1A49"/>
+            </a:solidFill>
+            <a:prstDash val="solid"/>
+          </a:ln>
+        </p:spPr>
+      </p:sp>
+      <p:pic>
+        <p:nvPicPr>
+          <p:cNvPr id="43" name="Icône Tuteur IA" descr="preencoded.png">    </p:cNvPr>
+          <p:cNvPicPr>
+            <a:picLocks noChangeAspect="1"/>
+          </p:cNvPicPr>
+          <p:nvPr/>
+        </p:nvPicPr>
+        <p:blipFill>
+          <a:blip r:embed="rId7"/>
+          <a:stretch>
+            <a:fillRect/>
+          </a:stretch>
+        </p:blipFill>
+        <p:spPr>
+          <a:xfrm>
+            <a:off x="10479024" y="1124712"/>
+            <a:ext cx="182880" cy="182880"/>
+          </a:xfrm>
+          <a:prstGeom prst="rect">
+            <a:avLst/>
+          </a:prstGeom>
+        </p:spPr>
+      </p:pic>
+      <p:sp>
+        <p:nvSpPr>
+          <p:cNvPr id="44" name="Titre Tuteur IA"/>
+          <p:cNvSpPr txBox="1"/>
+          <p:nvPr/>
+        </p:nvSpPr>
+        <p:spPr>
+          <a:xfrm>
+            <a:off x="10789920" y="1033272"/>
+            <a:ext cx="859536" cy="365760"/>
+          </a:xfrm>
+          <a:prstGeom prst="rect">
+            <a:avLst/>
+          </a:prstGeom>
+          <a:noFill/>
+          <a:ln/>
+        </p:spPr>
+        <p:txBody>
+          <a:bodyPr wrap="square" lIns="0" tIns="0" rIns="0" bIns="0" rtlCol="0" anchor="ctr"/>
+          <a:lstStyle/>
+          <a:p>
+            <a:pPr indent="0" marL="0">
+              <a:buNone/>
+            </a:pPr>
+            <a:r>
+              <a:rPr lang="en-US" sz="950" b="1" dirty="0">
+                <a:solidFill>
+                  <a:srgbClr val="152539"/>
+                </a:solidFill>
+                <a:latin typeface="Montserrat" pitchFamily="34" charset="0"/>
+                <a:ea typeface="Montserrat" pitchFamily="34" charset="-122"/>
+                <a:cs typeface="Montserrat" pitchFamily="34" charset="-120"/>
+              </a:rPr>
+              <a:t>Tuteur IA</a:t>
+            </a:r>
+            <a:endParaRPr lang="en-US" sz="950" dirty="0"/>
+          </a:p>
+        </p:txBody>
+      </p:sp>
+      <p:sp>
+        <p:nvSpPr>
+          <p:cNvPr id="45" name="Détail Tuteur IA"/>
+          <p:cNvSpPr txBox="1"/>
+          <p:nvPr/>
+        </p:nvSpPr>
+        <p:spPr>
+          <a:xfrm>
+            <a:off x="10405872" y="1417320"/>
+            <a:ext cx="1225296" cy="365760"/>
+          </a:xfrm>
+          <a:prstGeom prst="rect">
+            <a:avLst/>
+          </a:prstGeom>
+          <a:noFill/>
+          <a:ln/>
+        </p:spPr>
+        <p:txBody>
+          <a:bodyPr wrap="square" lIns="0" tIns="0" rIns="0" bIns="0" rtlCol="0" anchor="t"/>
+          <a:lstStyle/>
+          <a:p>
+            <a:pPr indent="0" marL="0">
+              <a:buNone/>
+            </a:pPr>
+            <a:r>
+              <a:rPr lang="en-US" sz="750" dirty="0">
+                <a:solidFill>
+                  <a:srgbClr val="475569"/>
+                </a:solidFill>
+                <a:latin typeface="Montserrat" pitchFamily="34" charset="0"/>
+                <a:ea typeface="Montserrat" pitchFamily="34" charset="-122"/>
+                <a:cs typeface="Montserrat" pitchFamily="34" charset="-120"/>
+              </a:rPr>
+              <a:t>feedback formatif, jamais une note</a:t>
+            </a:r>
+            <a:endParaRPr lang="en-US" sz="750" dirty="0"/>
+          </a:p>
+        </p:txBody>
+      </p:sp>
+      <p:sp>
+        <p:nvSpPr>
+          <p:cNvPr id="46" name="Retour 1"/>
+          <p:cNvSpPr/>
+          <p:nvPr/>
+        </p:nvSpPr>
+        <p:spPr>
+          <a:xfrm>
+            <a:off x="11009376" y="530352"/>
+            <a:ext cx="0" cy="128016"/>
+          </a:xfrm>
+          <a:prstGeom prst="line">
+            <a:avLst/>
+          </a:prstGeom>
+          <a:noFill/>
           <a:ln w="19050">
             <a:solidFill>
               <a:srgbClr val="BC1A49"/>
@@ -1964,30 +2265,77 @@
       </p:sp>
       <p:sp>
         <p:nvSpPr>
-          <p:cNvPr id="35" name="Date jalon 2"/>
-          <p:cNvSpPr txBox="1"/>
-          <p:nvPr/>
-        </p:nvSpPr>
-        <p:spPr>
-          <a:xfrm>
-            <a:off x="6320790" y="3364992"/>
-            <a:ext cx="1371600" cy="274320"/>
-          </a:xfrm>
-          <a:prstGeom prst="rect">
-            <a:avLst/>
-          </a:prstGeom>
-          <a:noFill/>
-          <a:ln/>
-        </p:spPr>
-        <p:txBody>
-          <a:bodyPr wrap="square" lIns="0" tIns="0" rIns="0" bIns="0" rtlCol="0" anchor="b"/>
+          <p:cNvPr id="47" name="Retour 2"/>
+          <p:cNvSpPr/>
+          <p:nvPr/>
+        </p:nvSpPr>
+        <p:spPr>
+          <a:xfrm>
+            <a:off x="4919472" y="530352"/>
+            <a:ext cx="6089904" cy="0"/>
+          </a:xfrm>
+          <a:prstGeom prst="line">
+            <a:avLst/>
+          </a:prstGeom>
+          <a:noFill/>
+          <a:ln w="19050">
+            <a:solidFill>
+              <a:srgbClr val="BC1A49"/>
+            </a:solidFill>
+            <a:prstDash val="solid"/>
+          </a:ln>
+        </p:spPr>
+      </p:sp>
+      <p:sp>
+        <p:nvSpPr>
+          <p:cNvPr id="48" name="Retour 3"/>
+          <p:cNvSpPr/>
+          <p:nvPr/>
+        </p:nvSpPr>
+        <p:spPr>
+          <a:xfrm>
+            <a:off x="4919472" y="530352"/>
+            <a:ext cx="0" cy="466344"/>
+          </a:xfrm>
+          <a:prstGeom prst="line">
+            <a:avLst/>
+          </a:prstGeom>
+          <a:noFill/>
+          <a:ln w="19050">
+            <a:solidFill>
+              <a:srgbClr val="BC1A49"/>
+            </a:solidFill>
+            <a:prstDash val="solid"/>
+            <a:tailEnd type="triangle"/>
+          </a:ln>
+        </p:spPr>
+      </p:sp>
+      <p:sp>
+        <p:nvSpPr>
+          <p:cNvPr id="49" name="Légende feedback"/>
+          <p:cNvSpPr txBox="1"/>
+          <p:nvPr/>
+        </p:nvSpPr>
+        <p:spPr>
+          <a:xfrm>
+            <a:off x="7498080" y="301752"/>
+            <a:ext cx="2926080" cy="201168"/>
+          </a:xfrm>
+          <a:prstGeom prst="rect">
+            <a:avLst/>
+          </a:prstGeom>
+          <a:noFill/>
+          <a:ln/>
+        </p:spPr>
+        <p:txBody>
+          <a:bodyPr wrap="square" lIns="0" tIns="0" rIns="0" bIns="0" rtlCol="0" anchor="ctr"/>
           <a:lstStyle/>
           <a:p>
             <a:pPr algn="ctr" indent="0" marL="0">
               <a:buNone/>
             </a:pPr>
             <a:r>
-              <a:rPr lang="en-US" sz="1100" b="1" dirty="0">
+              <a:rPr lang="en-US" sz="800" i="1" dirty="0">
                 <a:solidFill>
                   <a:srgbClr val="BC1A49"/>
                 </a:solidFill>
@@ -1995,22 +2343,783 @@
                 <a:ea typeface="Montserrat" pitchFamily="34" charset="-122"/>
                 <a:cs typeface="Montserrat" pitchFamily="34" charset="-120"/>
               </a:rPr>
+              <a:t>feedback en moins d'une minute</a:t>
+            </a:r>
+            <a:endParaRPr lang="en-US" sz="800" dirty="0"/>
+          </a:p>
+        </p:txBody>
+      </p:sp>
+      <p:sp>
+        <p:nvSpPr>
+          <p:cNvPr id="50" name="Flèche traces"/>
+          <p:cNvSpPr/>
+          <p:nvPr/>
+        </p:nvSpPr>
+        <p:spPr>
+          <a:xfrm>
+            <a:off x="9464040" y="1956816"/>
+            <a:ext cx="0" cy="283464"/>
+          </a:xfrm>
+          <a:prstGeom prst="line">
+            <a:avLst/>
+          </a:prstGeom>
+          <a:noFill/>
+          <a:ln w="19050">
+            <a:solidFill>
+              <a:srgbClr val="522582"/>
+            </a:solidFill>
+            <a:prstDash val="solid"/>
+            <a:tailEnd type="triangle"/>
+          </a:ln>
+        </p:spPr>
+      </p:sp>
+      <p:sp>
+        <p:nvSpPr>
+          <p:cNvPr id="51" name="Légende traces"/>
+          <p:cNvSpPr txBox="1"/>
+          <p:nvPr/>
+        </p:nvSpPr>
+        <p:spPr>
+          <a:xfrm>
+            <a:off x="9555480" y="1984248"/>
+            <a:ext cx="2194560" cy="201168"/>
+          </a:xfrm>
+          <a:prstGeom prst="rect">
+            <a:avLst/>
+          </a:prstGeom>
+          <a:noFill/>
+          <a:ln/>
+        </p:spPr>
+        <p:txBody>
+          <a:bodyPr wrap="square" lIns="0" tIns="0" rIns="0" bIns="0" rtlCol="0" anchor="ctr"/>
+          <a:lstStyle/>
+          <a:p>
+            <a:pPr indent="0" marL="0">
+              <a:buNone/>
+            </a:pPr>
+            <a:r>
+              <a:rPr lang="en-US" sz="750" i="1" dirty="0">
+                <a:solidFill>
+                  <a:srgbClr val="522582"/>
+                </a:solidFill>
+                <a:latin typeface="Montserrat" pitchFamily="34" charset="0"/>
+                <a:ea typeface="Montserrat" pitchFamily="34" charset="-122"/>
+                <a:cs typeface="Montserrat" pitchFamily="34" charset="-120"/>
+              </a:rPr>
+              <a:t>traces, soumissions, versions</a:t>
+            </a:r>
+            <a:endParaRPr lang="en-US" sz="750" dirty="0"/>
+          </a:p>
+        </p:txBody>
+      </p:sp>
+      <p:sp>
+        <p:nvSpPr>
+          <p:cNvPr id="52" name="Brique LLM"/>
+          <p:cNvSpPr/>
+          <p:nvPr/>
+        </p:nvSpPr>
+        <p:spPr>
+          <a:xfrm>
+            <a:off x="8778240" y="2258568"/>
+            <a:ext cx="1371600" cy="694944"/>
+          </a:xfrm>
+          <a:prstGeom prst="roundRect">
+            <a:avLst>
+              <a:gd name="adj" fmla="val 7895"/>
+            </a:avLst>
+          </a:prstGeom>
+          <a:solidFill>
+            <a:srgbClr val="FFFFFF"/>
+          </a:solidFill>
+          <a:ln w="15875">
+            <a:solidFill>
+              <a:srgbClr val="522582"/>
+            </a:solidFill>
+            <a:prstDash val="solid"/>
+          </a:ln>
+        </p:spPr>
+      </p:sp>
+      <p:sp>
+        <p:nvSpPr>
+          <p:cNvPr id="53" name="Pastille LLM"/>
+          <p:cNvSpPr/>
+          <p:nvPr/>
+        </p:nvSpPr>
+        <p:spPr>
+          <a:xfrm>
+            <a:off x="8869680" y="2350008"/>
+            <a:ext cx="329184" cy="329184"/>
+          </a:xfrm>
+          <a:prstGeom prst="ellipse">
+            <a:avLst/>
+          </a:prstGeom>
+          <a:solidFill>
+            <a:srgbClr val="522582"/>
+          </a:solidFill>
+          <a:ln w="12700">
+            <a:solidFill>
+              <a:srgbClr val="522582"/>
+            </a:solidFill>
+            <a:prstDash val="solid"/>
+          </a:ln>
+        </p:spPr>
+      </p:sp>
+      <p:pic>
+        <p:nvPicPr>
+          <p:cNvPr id="54" name="Icône LLM" descr="preencoded.png">    </p:cNvPr>
+          <p:cNvPicPr>
+            <a:picLocks noChangeAspect="1"/>
+          </p:cNvPicPr>
+          <p:nvPr/>
+        </p:nvPicPr>
+        <p:blipFill>
+          <a:blip r:embed="rId8"/>
+          <a:stretch>
+            <a:fillRect/>
+          </a:stretch>
+        </p:blipFill>
+        <p:spPr>
+          <a:xfrm>
+            <a:off x="8942832" y="2423160"/>
+            <a:ext cx="182880" cy="182880"/>
+          </a:xfrm>
+          <a:prstGeom prst="rect">
+            <a:avLst/>
+          </a:prstGeom>
+        </p:spPr>
+      </p:pic>
+      <p:sp>
+        <p:nvSpPr>
+          <p:cNvPr id="55" name="Titre LLM"/>
+          <p:cNvSpPr txBox="1"/>
+          <p:nvPr/>
+        </p:nvSpPr>
+        <p:spPr>
+          <a:xfrm>
+            <a:off x="9253728" y="2331720"/>
+            <a:ext cx="841248" cy="365760"/>
+          </a:xfrm>
+          <a:prstGeom prst="rect">
+            <a:avLst/>
+          </a:prstGeom>
+          <a:noFill/>
+          <a:ln/>
+        </p:spPr>
+        <p:txBody>
+          <a:bodyPr wrap="square" lIns="0" tIns="0" rIns="0" bIns="0" rtlCol="0" anchor="ctr"/>
+          <a:lstStyle/>
+          <a:p>
+            <a:pPr indent="0" marL="0">
+              <a:buNone/>
+            </a:pPr>
+            <a:r>
+              <a:rPr lang="en-US" sz="950" b="1" dirty="0">
+                <a:solidFill>
+                  <a:srgbClr val="152539"/>
+                </a:solidFill>
+                <a:latin typeface="Montserrat" pitchFamily="34" charset="0"/>
+                <a:ea typeface="Montserrat" pitchFamily="34" charset="-122"/>
+                <a:cs typeface="Montserrat" pitchFamily="34" charset="-120"/>
+              </a:rPr>
+              <a:t>Notre LLM</a:t>
+            </a:r>
+            <a:endParaRPr lang="en-US" sz="950" dirty="0"/>
+          </a:p>
+        </p:txBody>
+      </p:sp>
+      <p:sp>
+        <p:nvSpPr>
+          <p:cNvPr id="56" name="Détail LLM"/>
+          <p:cNvSpPr txBox="1"/>
+          <p:nvPr/>
+        </p:nvSpPr>
+        <p:spPr>
+          <a:xfrm>
+            <a:off x="8869680" y="2715768"/>
+            <a:ext cx="1207008" cy="192024"/>
+          </a:xfrm>
+          <a:prstGeom prst="rect">
+            <a:avLst/>
+          </a:prstGeom>
+          <a:noFill/>
+          <a:ln/>
+        </p:spPr>
+        <p:txBody>
+          <a:bodyPr wrap="square" lIns="0" tIns="0" rIns="0" bIns="0" rtlCol="0" anchor="t"/>
+          <a:lstStyle/>
+          <a:p>
+            <a:pPr indent="0" marL="0">
+              <a:buNone/>
+            </a:pPr>
+            <a:r>
+              <a:rPr lang="en-US" sz="750" dirty="0">
+                <a:solidFill>
+                  <a:srgbClr val="475569"/>
+                </a:solidFill>
+                <a:latin typeface="Montserrat" pitchFamily="34" charset="0"/>
+                <a:ea typeface="Montserrat" pitchFamily="34" charset="-122"/>
+                <a:cs typeface="Montserrat" pitchFamily="34" charset="-120"/>
+              </a:rPr>
+              <a:t>analyse des parcours</a:t>
+            </a:r>
+            <a:endParaRPr lang="en-US" sz="750" dirty="0"/>
+          </a:p>
+        </p:txBody>
+      </p:sp>
+      <p:sp>
+        <p:nvSpPr>
+          <p:cNvPr id="57" name="Flèche LLM → vue"/>
+          <p:cNvSpPr/>
+          <p:nvPr/>
+        </p:nvSpPr>
+        <p:spPr>
+          <a:xfrm flipH="1">
+            <a:off x="8522208" y="2606040"/>
+            <a:ext cx="228600" cy="0"/>
+          </a:xfrm>
+          <a:prstGeom prst="line">
+            <a:avLst/>
+          </a:prstGeom>
+          <a:noFill/>
+          <a:ln w="19050">
+            <a:solidFill>
+              <a:srgbClr val="522582"/>
+            </a:solidFill>
+            <a:prstDash val="solid"/>
+            <a:tailEnd type="triangle"/>
+          </a:ln>
+        </p:spPr>
+      </p:sp>
+      <p:sp>
+        <p:nvSpPr>
+          <p:cNvPr id="58" name="Brique Vue enseignant"/>
+          <p:cNvSpPr/>
+          <p:nvPr/>
+        </p:nvSpPr>
+        <p:spPr>
+          <a:xfrm>
+            <a:off x="6309360" y="2258568"/>
+            <a:ext cx="2194560" cy="694944"/>
+          </a:xfrm>
+          <a:prstGeom prst="roundRect">
+            <a:avLst>
+              <a:gd name="adj" fmla="val 7895"/>
+            </a:avLst>
+          </a:prstGeom>
+          <a:solidFill>
+            <a:srgbClr val="FFFFFF"/>
+          </a:solidFill>
+          <a:ln w="15875">
+            <a:solidFill>
+              <a:srgbClr val="522582"/>
+            </a:solidFill>
+            <a:prstDash val="solid"/>
+          </a:ln>
+        </p:spPr>
+      </p:sp>
+      <p:sp>
+        <p:nvSpPr>
+          <p:cNvPr id="59" name="Pastille Vue enseignant"/>
+          <p:cNvSpPr/>
+          <p:nvPr/>
+        </p:nvSpPr>
+        <p:spPr>
+          <a:xfrm>
+            <a:off x="6400800" y="2350008"/>
+            <a:ext cx="329184" cy="329184"/>
+          </a:xfrm>
+          <a:prstGeom prst="ellipse">
+            <a:avLst/>
+          </a:prstGeom>
+          <a:solidFill>
+            <a:srgbClr val="522582"/>
+          </a:solidFill>
+          <a:ln w="12700">
+            <a:solidFill>
+              <a:srgbClr val="522582"/>
+            </a:solidFill>
+            <a:prstDash val="solid"/>
+          </a:ln>
+        </p:spPr>
+      </p:sp>
+      <p:pic>
+        <p:nvPicPr>
+          <p:cNvPr id="60" name="Icône Vue enseignant" descr="preencoded.png">    </p:cNvPr>
+          <p:cNvPicPr>
+            <a:picLocks noChangeAspect="1"/>
+          </p:cNvPicPr>
+          <p:nvPr/>
+        </p:nvPicPr>
+        <p:blipFill>
+          <a:blip r:embed="rId9"/>
+          <a:stretch>
+            <a:fillRect/>
+          </a:stretch>
+        </p:blipFill>
+        <p:spPr>
+          <a:xfrm>
+            <a:off x="6473952" y="2423160"/>
+            <a:ext cx="182880" cy="182880"/>
+          </a:xfrm>
+          <a:prstGeom prst="rect">
+            <a:avLst/>
+          </a:prstGeom>
+        </p:spPr>
+      </p:pic>
+      <p:sp>
+        <p:nvSpPr>
+          <p:cNvPr id="61" name="Titre Vue enseignant"/>
+          <p:cNvSpPr txBox="1"/>
+          <p:nvPr/>
+        </p:nvSpPr>
+        <p:spPr>
+          <a:xfrm>
+            <a:off x="6784848" y="2331720"/>
+            <a:ext cx="1664208" cy="365760"/>
+          </a:xfrm>
+          <a:prstGeom prst="rect">
+            <a:avLst/>
+          </a:prstGeom>
+          <a:noFill/>
+          <a:ln/>
+        </p:spPr>
+        <p:txBody>
+          <a:bodyPr wrap="square" lIns="0" tIns="0" rIns="0" bIns="0" rtlCol="0" anchor="ctr"/>
+          <a:lstStyle/>
+          <a:p>
+            <a:pPr indent="0" marL="0">
+              <a:buNone/>
+            </a:pPr>
+            <a:r>
+              <a:rPr lang="en-US" sz="950" b="1" dirty="0">
+                <a:solidFill>
+                  <a:srgbClr val="152539"/>
+                </a:solidFill>
+                <a:latin typeface="Montserrat" pitchFamily="34" charset="0"/>
+                <a:ea typeface="Montserrat" pitchFamily="34" charset="-122"/>
+                <a:cs typeface="Montserrat" pitchFamily="34" charset="-120"/>
+              </a:rPr>
+              <a:t>Vue enseignant</a:t>
+            </a:r>
+            <a:endParaRPr lang="en-US" sz="950" dirty="0"/>
+          </a:p>
+        </p:txBody>
+      </p:sp>
+      <p:sp>
+        <p:nvSpPr>
+          <p:cNvPr id="62" name="Détail Vue enseignant"/>
+          <p:cNvSpPr txBox="1"/>
+          <p:nvPr/>
+        </p:nvSpPr>
+        <p:spPr>
+          <a:xfrm>
+            <a:off x="6400800" y="2715768"/>
+            <a:ext cx="2029968" cy="192024"/>
+          </a:xfrm>
+          <a:prstGeom prst="rect">
+            <a:avLst/>
+          </a:prstGeom>
+          <a:noFill/>
+          <a:ln/>
+        </p:spPr>
+        <p:txBody>
+          <a:bodyPr wrap="square" lIns="0" tIns="0" rIns="0" bIns="0" rtlCol="0" anchor="t"/>
+          <a:lstStyle/>
+          <a:p>
+            <a:pPr indent="0" marL="0">
+              <a:buNone/>
+            </a:pPr>
+            <a:r>
+              <a:rPr lang="en-US" sz="750" dirty="0">
+                <a:solidFill>
+                  <a:srgbClr val="475569"/>
+                </a:solidFill>
+                <a:latin typeface="Montserrat" pitchFamily="34" charset="0"/>
+                <a:ea typeface="Montserrat" pitchFamily="34" charset="-122"/>
+                <a:cs typeface="Montserrat" pitchFamily="34" charset="-120"/>
+              </a:rPr>
+              <a:t>résumé de séance · difficultés et concepts mal maîtrisés · versions soumises</a:t>
+            </a:r>
+            <a:endParaRPr lang="en-US" sz="750" dirty="0"/>
+          </a:p>
+        </p:txBody>
+      </p:sp>
+      <p:sp>
+        <p:nvSpPr>
+          <p:cNvPr id="63" name="Flèche vue → enseignant"/>
+          <p:cNvSpPr/>
+          <p:nvPr/>
+        </p:nvSpPr>
+        <p:spPr>
+          <a:xfrm flipH="1">
+            <a:off x="6144768" y="2606040"/>
+            <a:ext cx="137160" cy="0"/>
+          </a:xfrm>
+          <a:prstGeom prst="line">
+            <a:avLst/>
+          </a:prstGeom>
+          <a:noFill/>
+          <a:ln w="19050">
+            <a:solidFill>
+              <a:srgbClr val="522582"/>
+            </a:solidFill>
+            <a:prstDash val="solid"/>
+            <a:tailEnd type="triangle"/>
+          </a:ln>
+        </p:spPr>
+      </p:sp>
+      <p:sp>
+        <p:nvSpPr>
+          <p:cNvPr id="64" name="Acteur Enseignant"/>
+          <p:cNvSpPr/>
+          <p:nvPr/>
+        </p:nvSpPr>
+        <p:spPr>
+          <a:xfrm>
+            <a:off x="4645152" y="2331720"/>
+            <a:ext cx="548640" cy="548640"/>
+          </a:xfrm>
+          <a:prstGeom prst="ellipse">
+            <a:avLst/>
+          </a:prstGeom>
+          <a:solidFill>
+            <a:srgbClr val="152539"/>
+          </a:solidFill>
+          <a:ln w="12700">
+            <a:solidFill>
+              <a:srgbClr val="152539"/>
+            </a:solidFill>
+            <a:prstDash val="solid"/>
+          </a:ln>
+        </p:spPr>
+      </p:sp>
+      <p:pic>
+        <p:nvPicPr>
+          <p:cNvPr id="65" name="Icône Enseignant" descr="preencoded.png">    </p:cNvPr>
+          <p:cNvPicPr>
+            <a:picLocks noChangeAspect="1"/>
+          </p:cNvPicPr>
+          <p:nvPr/>
+        </p:nvPicPr>
+        <p:blipFill>
+          <a:blip r:embed="rId10"/>
+          <a:stretch>
+            <a:fillRect/>
+          </a:stretch>
+        </p:blipFill>
+        <p:spPr>
+          <a:xfrm>
+            <a:off x="4773168" y="2459736"/>
+            <a:ext cx="292608" cy="292608"/>
+          </a:xfrm>
+          <a:prstGeom prst="rect">
+            <a:avLst/>
+          </a:prstGeom>
+        </p:spPr>
+      </p:pic>
+      <p:sp>
+        <p:nvSpPr>
+          <p:cNvPr id="66" name="Nom Enseignant"/>
+          <p:cNvSpPr txBox="1"/>
+          <p:nvPr/>
+        </p:nvSpPr>
+        <p:spPr>
+          <a:xfrm>
+            <a:off x="4416552" y="2916936"/>
+            <a:ext cx="1005840" cy="219456"/>
+          </a:xfrm>
+          <a:prstGeom prst="rect">
+            <a:avLst/>
+          </a:prstGeom>
+          <a:noFill/>
+          <a:ln/>
+        </p:spPr>
+        <p:txBody>
+          <a:bodyPr wrap="square" lIns="0" tIns="0" rIns="0" bIns="0" rtlCol="0" anchor="t"/>
+          <a:lstStyle/>
+          <a:p>
+            <a:pPr algn="ctr" indent="0" marL="0">
+              <a:buNone/>
+            </a:pPr>
+            <a:r>
+              <a:rPr lang="en-US" sz="850" b="1" dirty="0">
+                <a:solidFill>
+                  <a:srgbClr val="152539"/>
+                </a:solidFill>
+                <a:latin typeface="Montserrat" pitchFamily="34" charset="0"/>
+                <a:ea typeface="Montserrat" pitchFamily="34" charset="-122"/>
+                <a:cs typeface="Montserrat" pitchFamily="34" charset="-120"/>
+              </a:rPr>
+              <a:t>Enseignant</a:t>
+            </a:r>
+            <a:endParaRPr lang="en-US" sz="850" dirty="0"/>
+          </a:p>
+        </p:txBody>
+      </p:sp>
+      <p:sp>
+        <p:nvSpPr>
+          <p:cNvPr id="67" name="Label feuille de route"/>
+          <p:cNvSpPr txBox="1"/>
+          <p:nvPr/>
+        </p:nvSpPr>
+        <p:spPr>
+          <a:xfrm>
+            <a:off x="4617720" y="3200400"/>
+            <a:ext cx="2743200" cy="219456"/>
+          </a:xfrm>
+          <a:prstGeom prst="rect">
+            <a:avLst/>
+          </a:prstGeom>
+          <a:noFill/>
+          <a:ln/>
+        </p:spPr>
+        <p:txBody>
+          <a:bodyPr wrap="square" lIns="0" tIns="0" rIns="0" bIns="0" rtlCol="0" anchor="ctr"/>
+          <a:lstStyle/>
+          <a:p>
+            <a:pPr indent="0" marL="0">
+              <a:buNone/>
+            </a:pPr>
+            <a:r>
+              <a:rPr lang="en-US" sz="900" b="1" spc="250" kern="0" dirty="0">
+                <a:solidFill>
+                  <a:srgbClr val="01A6E0"/>
+                </a:solidFill>
+                <a:latin typeface="Montserrat" pitchFamily="34" charset="0"/>
+                <a:ea typeface="Montserrat" pitchFamily="34" charset="-122"/>
+                <a:cs typeface="Montserrat" pitchFamily="34" charset="-120"/>
+              </a:rPr>
+              <a:t>FEUILLE DE ROUTE</a:t>
+            </a:r>
+            <a:endParaRPr lang="en-US" sz="900" dirty="0"/>
+          </a:p>
+        </p:txBody>
+      </p:sp>
+      <p:sp>
+        <p:nvSpPr>
+          <p:cNvPr id="68" name="Chevron Sept. 2026"/>
+          <p:cNvSpPr/>
+          <p:nvPr/>
+        </p:nvSpPr>
+        <p:spPr>
+          <a:xfrm>
+            <a:off x="4617720" y="3611880"/>
+            <a:ext cx="1463040" cy="566928"/>
+          </a:xfrm>
+          <a:prstGeom prst="homePlate">
+            <a:avLst/>
+          </a:prstGeom>
+          <a:solidFill>
+            <a:srgbClr val="01A6E0"/>
+          </a:solidFill>
+          <a:ln w="12700">
+            <a:solidFill>
+              <a:srgbClr val="FFFFFF"/>
+            </a:solidFill>
+            <a:prstDash val="solid"/>
+          </a:ln>
+        </p:spPr>
+      </p:sp>
+      <p:sp>
+        <p:nvSpPr>
+          <p:cNvPr id="69" name="Date Sept. 2026"/>
+          <p:cNvSpPr txBox="1"/>
+          <p:nvPr/>
+        </p:nvSpPr>
+        <p:spPr>
+          <a:xfrm>
+            <a:off x="4709160" y="3611880"/>
+            <a:ext cx="1005840" cy="566928"/>
+          </a:xfrm>
+          <a:prstGeom prst="rect">
+            <a:avLst/>
+          </a:prstGeom>
+          <a:noFill/>
+          <a:ln/>
+        </p:spPr>
+        <p:txBody>
+          <a:bodyPr wrap="square" lIns="0" tIns="0" rIns="0" bIns="0" rtlCol="0" anchor="ctr"/>
+          <a:lstStyle/>
+          <a:p>
+            <a:pPr algn="ctr" indent="0" marL="0">
+              <a:buNone/>
+            </a:pPr>
+            <a:r>
+              <a:rPr lang="en-US" sz="1000" b="1" dirty="0">
+                <a:solidFill>
+                  <a:srgbClr val="FFFFFF"/>
+                </a:solidFill>
+                <a:latin typeface="Montserrat" pitchFamily="34" charset="0"/>
+                <a:ea typeface="Montserrat" pitchFamily="34" charset="-122"/>
+                <a:cs typeface="Montserrat" pitchFamily="34" charset="-120"/>
+              </a:rPr>
+              <a:t>Sept. 2026</a:t>
+            </a:r>
+            <a:endParaRPr lang="en-US" sz="1000" dirty="0"/>
+          </a:p>
+        </p:txBody>
+      </p:sp>
+      <p:pic>
+        <p:nvPicPr>
+          <p:cNvPr id="70" name="Icône Sept. 2026" descr="preencoded.png">    </p:cNvPr>
+          <p:cNvPicPr>
+            <a:picLocks noChangeAspect="1"/>
+          </p:cNvPicPr>
+          <p:nvPr/>
+        </p:nvPicPr>
+        <p:blipFill>
+          <a:blip r:embed="rId11"/>
+          <a:stretch>
+            <a:fillRect/>
+          </a:stretch>
+        </p:blipFill>
+        <p:spPr>
+          <a:xfrm>
+            <a:off x="4690872" y="4270248"/>
+            <a:ext cx="201168" cy="201168"/>
+          </a:xfrm>
+          <a:prstGeom prst="rect">
+            <a:avLst/>
+          </a:prstGeom>
+        </p:spPr>
+      </p:pic>
+      <p:sp>
+        <p:nvSpPr>
+          <p:cNvPr id="71" name="Texte Sept. 2026"/>
+          <p:cNvSpPr txBox="1"/>
+          <p:nvPr/>
+        </p:nvSpPr>
+        <p:spPr>
+          <a:xfrm>
+            <a:off x="4946904" y="4251960"/>
+            <a:ext cx="1005840" cy="566928"/>
+          </a:xfrm>
+          <a:prstGeom prst="rect">
+            <a:avLst/>
+          </a:prstGeom>
+          <a:noFill/>
+          <a:ln/>
+        </p:spPr>
+        <p:txBody>
+          <a:bodyPr wrap="square" lIns="0" tIns="0" rIns="0" bIns="0" rtlCol="0" anchor="t"/>
+          <a:lstStyle/>
+          <a:p>
+            <a:pPr indent="0" marL="0">
+              <a:buNone/>
+            </a:pPr>
+            <a:r>
+              <a:rPr lang="en-US" sz="800" dirty="0">
+                <a:solidFill>
+                  <a:srgbClr val="475569"/>
+                </a:solidFill>
+                <a:latin typeface="Montserrat" pitchFamily="34" charset="0"/>
+                <a:ea typeface="Montserrat" pitchFamily="34" charset="-122"/>
+                <a:cs typeface="Montserrat" pitchFamily="34" charset="-120"/>
+              </a:rPr>
+              <a:t>Kick-off, deux scénarios choisis</a:t>
+            </a:r>
+            <a:endParaRPr lang="en-US" sz="800" dirty="0"/>
+          </a:p>
+        </p:txBody>
+      </p:sp>
+      <p:sp>
+        <p:nvSpPr>
+          <p:cNvPr id="72" name="Chevron 13 nov. 2026"/>
+          <p:cNvSpPr/>
+          <p:nvPr/>
+        </p:nvSpPr>
+        <p:spPr>
+          <a:xfrm>
+            <a:off x="6044184" y="3611880"/>
+            <a:ext cx="1463040" cy="566928"/>
+          </a:xfrm>
+          <a:prstGeom prst="chevron">
+            <a:avLst/>
+          </a:prstGeom>
+          <a:solidFill>
+            <a:srgbClr val="BC1A49"/>
+          </a:solidFill>
+          <a:ln w="12700">
+            <a:solidFill>
+              <a:srgbClr val="FFFFFF"/>
+            </a:solidFill>
+            <a:prstDash val="solid"/>
+          </a:ln>
+        </p:spPr>
+      </p:sp>
+      <p:sp>
+        <p:nvSpPr>
+          <p:cNvPr id="73" name="Date 13 nov. 2026"/>
+          <p:cNvSpPr txBox="1"/>
+          <p:nvPr/>
+        </p:nvSpPr>
+        <p:spPr>
+          <a:xfrm>
+            <a:off x="6300216" y="3611880"/>
+            <a:ext cx="1005840" cy="566928"/>
+          </a:xfrm>
+          <a:prstGeom prst="rect">
+            <a:avLst/>
+          </a:prstGeom>
+          <a:noFill/>
+          <a:ln/>
+        </p:spPr>
+        <p:txBody>
+          <a:bodyPr wrap="square" lIns="0" tIns="0" rIns="0" bIns="0" rtlCol="0" anchor="ctr"/>
+          <a:lstStyle/>
+          <a:p>
+            <a:pPr algn="ctr" indent="0" marL="0">
+              <a:buNone/>
+            </a:pPr>
+            <a:r>
+              <a:rPr lang="en-US" sz="1050" b="1" dirty="0">
+                <a:solidFill>
+                  <a:srgbClr val="FFFFFF"/>
+                </a:solidFill>
+                <a:latin typeface="Montserrat" pitchFamily="34" charset="0"/>
+                <a:ea typeface="Montserrat" pitchFamily="34" charset="-122"/>
+                <a:cs typeface="Montserrat" pitchFamily="34" charset="-120"/>
+              </a:rPr>
               <a:t>13 nov. 2026</a:t>
             </a:r>
-            <a:endParaRPr lang="en-US" sz="1100" dirty="0"/>
-          </a:p>
-        </p:txBody>
-      </p:sp>
-      <p:sp>
-        <p:nvSpPr>
-          <p:cNvPr id="36" name="Texte jalon 2"/>
-          <p:cNvSpPr txBox="1"/>
-          <p:nvPr/>
-        </p:nvSpPr>
-        <p:spPr>
-          <a:xfrm>
-            <a:off x="6320790" y="4187952"/>
-            <a:ext cx="1371600" cy="502920"/>
+            <a:endParaRPr lang="en-US" sz="1050" dirty="0"/>
+          </a:p>
+        </p:txBody>
+      </p:sp>
+      <p:pic>
+        <p:nvPicPr>
+          <p:cNvPr id="74" name="Icône 13 nov. 2026" descr="preencoded.png">    </p:cNvPr>
+          <p:cNvPicPr>
+            <a:picLocks noChangeAspect="1"/>
+          </p:cNvPicPr>
+          <p:nvPr/>
+        </p:nvPicPr>
+        <p:blipFill>
+          <a:blip r:embed="rId12"/>
+          <a:stretch>
+            <a:fillRect/>
+          </a:stretch>
+        </p:blipFill>
+        <p:spPr>
+          <a:xfrm>
+            <a:off x="6117336" y="4270248"/>
+            <a:ext cx="201168" cy="201168"/>
+          </a:xfrm>
+          <a:prstGeom prst="rect">
+            <a:avLst/>
+          </a:prstGeom>
+        </p:spPr>
+      </p:pic>
+      <p:sp>
+        <p:nvSpPr>
+          <p:cNvPr id="75" name="Texte 13 nov. 2026"/>
+          <p:cNvSpPr txBox="1"/>
+          <p:nvPr/>
+        </p:nvSpPr>
+        <p:spPr>
+          <a:xfrm>
+            <a:off x="6373368" y="4251960"/>
+            <a:ext cx="1005840" cy="566928"/>
           </a:xfrm>
           <a:prstGeom prst="rect">
             <a:avLst/>
@@ -2022,11 +3131,138 @@
           <a:bodyPr wrap="square" lIns="0" tIns="0" rIns="0" bIns="0" rtlCol="0" anchor="t"/>
           <a:lstStyle/>
           <a:p>
+            <a:pPr indent="0" marL="0">
+              <a:buNone/>
+            </a:pPr>
+            <a:r>
+              <a:rPr lang="en-US" sz="800" dirty="0">
+                <a:solidFill>
+                  <a:srgbClr val="475569"/>
+                </a:solidFill>
+                <a:latin typeface="Montserrat" pitchFamily="34" charset="0"/>
+                <a:ea typeface="Montserrat" pitchFamily="34" charset="-122"/>
+                <a:cs typeface="Montserrat" pitchFamily="34" charset="-120"/>
+              </a:rPr>
+              <a:t>Bêta MVP en classe, fraude et scoring crédit</a:t>
+            </a:r>
+            <a:endParaRPr lang="en-US" sz="800" dirty="0"/>
+          </a:p>
+        </p:txBody>
+      </p:sp>
+      <p:sp>
+        <p:nvSpPr>
+          <p:cNvPr id="76" name="Chevron Fév. 2027"/>
+          <p:cNvSpPr/>
+          <p:nvPr/>
+        </p:nvSpPr>
+        <p:spPr>
+          <a:xfrm>
+            <a:off x="7470648" y="3611880"/>
+            <a:ext cx="1463040" cy="566928"/>
+          </a:xfrm>
+          <a:prstGeom prst="chevron">
+            <a:avLst/>
+          </a:prstGeom>
+          <a:solidFill>
+            <a:srgbClr val="0078BF"/>
+          </a:solidFill>
+          <a:ln w="12700">
+            <a:solidFill>
+              <a:srgbClr val="FFFFFF"/>
+            </a:solidFill>
+            <a:prstDash val="solid"/>
+          </a:ln>
+        </p:spPr>
+      </p:sp>
+      <p:sp>
+        <p:nvSpPr>
+          <p:cNvPr id="77" name="Date Fév. 2027"/>
+          <p:cNvSpPr txBox="1"/>
+          <p:nvPr/>
+        </p:nvSpPr>
+        <p:spPr>
+          <a:xfrm>
+            <a:off x="7726680" y="3611880"/>
+            <a:ext cx="1005840" cy="566928"/>
+          </a:xfrm>
+          <a:prstGeom prst="rect">
+            <a:avLst/>
+          </a:prstGeom>
+          <a:noFill/>
+          <a:ln/>
+        </p:spPr>
+        <p:txBody>
+          <a:bodyPr wrap="square" lIns="0" tIns="0" rIns="0" bIns="0" rtlCol="0" anchor="ctr"/>
+          <a:lstStyle/>
+          <a:p>
             <a:pPr algn="ctr" indent="0" marL="0">
               <a:buNone/>
             </a:pPr>
             <a:r>
-              <a:rPr lang="en-US" sz="850" dirty="0">
+              <a:rPr lang="en-US" sz="1000" b="1" dirty="0">
+                <a:solidFill>
+                  <a:srgbClr val="FFFFFF"/>
+                </a:solidFill>
+                <a:latin typeface="Montserrat" pitchFamily="34" charset="0"/>
+                <a:ea typeface="Montserrat" pitchFamily="34" charset="-122"/>
+                <a:cs typeface="Montserrat" pitchFamily="34" charset="-120"/>
+              </a:rPr>
+              <a:t>Fév. 2027</a:t>
+            </a:r>
+            <a:endParaRPr lang="en-US" sz="1000" dirty="0"/>
+          </a:p>
+        </p:txBody>
+      </p:sp>
+      <p:pic>
+        <p:nvPicPr>
+          <p:cNvPr id="78" name="Icône Fév. 2027" descr="preencoded.png">    </p:cNvPr>
+          <p:cNvPicPr>
+            <a:picLocks noChangeAspect="1"/>
+          </p:cNvPicPr>
+          <p:nvPr/>
+        </p:nvPicPr>
+        <p:blipFill>
+          <a:blip r:embed="rId13"/>
+          <a:stretch>
+            <a:fillRect/>
+          </a:stretch>
+        </p:blipFill>
+        <p:spPr>
+          <a:xfrm>
+            <a:off x="7543800" y="4270248"/>
+            <a:ext cx="201168" cy="201168"/>
+          </a:xfrm>
+          <a:prstGeom prst="rect">
+            <a:avLst/>
+          </a:prstGeom>
+        </p:spPr>
+      </p:pic>
+      <p:sp>
+        <p:nvSpPr>
+          <p:cNvPr id="79" name="Texte Fév. 2027"/>
+          <p:cNvSpPr txBox="1"/>
+          <p:nvPr/>
+        </p:nvSpPr>
+        <p:spPr>
+          <a:xfrm>
+            <a:off x="7799832" y="4251960"/>
+            <a:ext cx="1005840" cy="566928"/>
+          </a:xfrm>
+          <a:prstGeom prst="rect">
+            <a:avLst/>
+          </a:prstGeom>
+          <a:noFill/>
+          <a:ln/>
+        </p:spPr>
+        <p:txBody>
+          <a:bodyPr wrap="square" lIns="0" tIns="0" rIns="0" bIns="0" rtlCol="0" anchor="t"/>
+          <a:lstStyle/>
+          <a:p>
+            <a:pPr indent="0" marL="0">
+              <a:buNone/>
+            </a:pPr>
+            <a:r>
+              <a:rPr lang="en-US" sz="800" dirty="0">
                 <a:solidFill>
                   <a:srgbClr val="475569"/>
                 </a:solidFill>
@@ -2034,30 +3270,284 @@
                 <a:ea typeface="Montserrat" pitchFamily="34" charset="-122"/>
                 <a:cs typeface="Montserrat" pitchFamily="34" charset="-120"/>
               </a:rPr>
-              <a:t>Bêta (MVP) en classe : fraude, scoring crédit</a:t>
-            </a:r>
-            <a:endParaRPr lang="en-US" sz="850" dirty="0"/>
-          </a:p>
-        </p:txBody>
-      </p:sp>
-      <p:sp>
-        <p:nvSpPr>
-          <p:cNvPr id="37" name="Jalon 3"/>
+              <a:t>Pilote élargi, 25+ apprentis Atlas</a:t>
+            </a:r>
+            <a:endParaRPr lang="en-US" sz="800" dirty="0"/>
+          </a:p>
+        </p:txBody>
+      </p:sp>
+      <p:sp>
+        <p:nvSpPr>
+          <p:cNvPr id="80" name="Chevron Juin 2027"/>
           <p:cNvSpPr/>
           <p:nvPr/>
         </p:nvSpPr>
         <p:spPr>
           <a:xfrm>
-            <a:off x="8343900" y="3840480"/>
-            <a:ext cx="182880" cy="182880"/>
-          </a:xfrm>
-          <a:prstGeom prst="ellipse">
-            <a:avLst/>
-          </a:prstGeom>
-          <a:solidFill>
-            <a:srgbClr val="FFFFFF"/>
-          </a:solidFill>
-          <a:ln w="19050">
+            <a:off x="8897112" y="3611880"/>
+            <a:ext cx="1463040" cy="566928"/>
+          </a:xfrm>
+          <a:prstGeom prst="chevron">
+            <a:avLst/>
+          </a:prstGeom>
+          <a:solidFill>
+            <a:srgbClr val="522582"/>
+          </a:solidFill>
+          <a:ln w="12700">
+            <a:solidFill>
+              <a:srgbClr val="FFFFFF"/>
+            </a:solidFill>
+            <a:prstDash val="solid"/>
+          </a:ln>
+        </p:spPr>
+      </p:sp>
+      <p:sp>
+        <p:nvSpPr>
+          <p:cNvPr id="81" name="Date Juin 2027"/>
+          <p:cNvSpPr txBox="1"/>
+          <p:nvPr/>
+        </p:nvSpPr>
+        <p:spPr>
+          <a:xfrm>
+            <a:off x="9153144" y="3611880"/>
+            <a:ext cx="1005840" cy="566928"/>
+          </a:xfrm>
+          <a:prstGeom prst="rect">
+            <a:avLst/>
+          </a:prstGeom>
+          <a:noFill/>
+          <a:ln/>
+        </p:spPr>
+        <p:txBody>
+          <a:bodyPr wrap="square" lIns="0" tIns="0" rIns="0" bIns="0" rtlCol="0" anchor="ctr"/>
+          <a:lstStyle/>
+          <a:p>
+            <a:pPr algn="ctr" indent="0" marL="0">
+              <a:buNone/>
+            </a:pPr>
+            <a:r>
+              <a:rPr lang="en-US" sz="1000" b="1" dirty="0">
+                <a:solidFill>
+                  <a:srgbClr val="FFFFFF"/>
+                </a:solidFill>
+                <a:latin typeface="Montserrat" pitchFamily="34" charset="0"/>
+                <a:ea typeface="Montserrat" pitchFamily="34" charset="-122"/>
+                <a:cs typeface="Montserrat" pitchFamily="34" charset="-120"/>
+              </a:rPr>
+              <a:t>Juin 2027</a:t>
+            </a:r>
+            <a:endParaRPr lang="en-US" sz="1000" dirty="0"/>
+          </a:p>
+        </p:txBody>
+      </p:sp>
+      <p:pic>
+        <p:nvPicPr>
+          <p:cNvPr id="82" name="Icône Juin 2027" descr="preencoded.png">    </p:cNvPr>
+          <p:cNvPicPr>
+            <a:picLocks noChangeAspect="1"/>
+          </p:cNvPicPr>
+          <p:nvPr/>
+        </p:nvPicPr>
+        <p:blipFill>
+          <a:blip r:embed="rId14"/>
+          <a:stretch>
+            <a:fillRect/>
+          </a:stretch>
+        </p:blipFill>
+        <p:spPr>
+          <a:xfrm>
+            <a:off x="8970264" y="4270248"/>
+            <a:ext cx="201168" cy="201168"/>
+          </a:xfrm>
+          <a:prstGeom prst="rect">
+            <a:avLst/>
+          </a:prstGeom>
+        </p:spPr>
+      </p:pic>
+      <p:sp>
+        <p:nvSpPr>
+          <p:cNvPr id="83" name="Texte Juin 2027"/>
+          <p:cNvSpPr txBox="1"/>
+          <p:nvPr/>
+        </p:nvSpPr>
+        <p:spPr>
+          <a:xfrm>
+            <a:off x="9226296" y="4251960"/>
+            <a:ext cx="1005840" cy="566928"/>
+          </a:xfrm>
+          <a:prstGeom prst="rect">
+            <a:avLst/>
+          </a:prstGeom>
+          <a:noFill/>
+          <a:ln/>
+        </p:spPr>
+        <p:txBody>
+          <a:bodyPr wrap="square" lIns="0" tIns="0" rIns="0" bIns="0" rtlCol="0" anchor="t"/>
+          <a:lstStyle/>
+          <a:p>
+            <a:pPr indent="0" marL="0">
+              <a:buNone/>
+            </a:pPr>
+            <a:r>
+              <a:rPr lang="en-US" sz="800" dirty="0">
+                <a:solidFill>
+                  <a:srgbClr val="475569"/>
+                </a:solidFill>
+                <a:latin typeface="Montserrat" pitchFamily="34" charset="0"/>
+                <a:ea typeface="Montserrat" pitchFamily="34" charset="-122"/>
+                <a:cs typeface="Montserrat" pitchFamily="34" charset="-120"/>
+              </a:rPr>
+              <a:t>Mi-parcours Atlas, retours tuteurs</a:t>
+            </a:r>
+            <a:endParaRPr lang="en-US" sz="800" dirty="0"/>
+          </a:p>
+        </p:txBody>
+      </p:sp>
+      <p:sp>
+        <p:nvSpPr>
+          <p:cNvPr id="84" name="Chevron Oct. 2027"/>
+          <p:cNvSpPr/>
+          <p:nvPr/>
+        </p:nvSpPr>
+        <p:spPr>
+          <a:xfrm>
+            <a:off x="10323576" y="3611880"/>
+            <a:ext cx="1463040" cy="566928"/>
+          </a:xfrm>
+          <a:prstGeom prst="chevron">
+            <a:avLst/>
+          </a:prstGeom>
+          <a:solidFill>
+            <a:srgbClr val="152539"/>
+          </a:solidFill>
+          <a:ln w="12700">
+            <a:solidFill>
+              <a:srgbClr val="FFFFFF"/>
+            </a:solidFill>
+            <a:prstDash val="solid"/>
+          </a:ln>
+        </p:spPr>
+      </p:sp>
+      <p:sp>
+        <p:nvSpPr>
+          <p:cNvPr id="85" name="Date Oct. 2027"/>
+          <p:cNvSpPr txBox="1"/>
+          <p:nvPr/>
+        </p:nvSpPr>
+        <p:spPr>
+          <a:xfrm>
+            <a:off x="10579608" y="3611880"/>
+            <a:ext cx="1005840" cy="566928"/>
+          </a:xfrm>
+          <a:prstGeom prst="rect">
+            <a:avLst/>
+          </a:prstGeom>
+          <a:noFill/>
+          <a:ln/>
+        </p:spPr>
+        <p:txBody>
+          <a:bodyPr wrap="square" lIns="0" tIns="0" rIns="0" bIns="0" rtlCol="0" anchor="ctr"/>
+          <a:lstStyle/>
+          <a:p>
+            <a:pPr algn="ctr" indent="0" marL="0">
+              <a:buNone/>
+            </a:pPr>
+            <a:r>
+              <a:rPr lang="en-US" sz="1000" b="1" dirty="0">
+                <a:solidFill>
+                  <a:srgbClr val="FFFFFF"/>
+                </a:solidFill>
+                <a:latin typeface="Montserrat" pitchFamily="34" charset="0"/>
+                <a:ea typeface="Montserrat" pitchFamily="34" charset="-122"/>
+                <a:cs typeface="Montserrat" pitchFamily="34" charset="-120"/>
+              </a:rPr>
+              <a:t>Oct. 2027</a:t>
+            </a:r>
+            <a:endParaRPr lang="en-US" sz="1000" dirty="0"/>
+          </a:p>
+        </p:txBody>
+      </p:sp>
+      <p:pic>
+        <p:nvPicPr>
+          <p:cNvPr id="86" name="Icône Oct. 2027" descr="preencoded.png">    </p:cNvPr>
+          <p:cNvPicPr>
+            <a:picLocks noChangeAspect="1"/>
+          </p:cNvPicPr>
+          <p:nvPr/>
+        </p:nvPicPr>
+        <p:blipFill>
+          <a:blip r:embed="rId15"/>
+          <a:stretch>
+            <a:fillRect/>
+          </a:stretch>
+        </p:blipFill>
+        <p:spPr>
+          <a:xfrm>
+            <a:off x="10396728" y="4270248"/>
+            <a:ext cx="201168" cy="201168"/>
+          </a:xfrm>
+          <a:prstGeom prst="rect">
+            <a:avLst/>
+          </a:prstGeom>
+        </p:spPr>
+      </p:pic>
+      <p:sp>
+        <p:nvSpPr>
+          <p:cNvPr id="87" name="Texte Oct. 2027"/>
+          <p:cNvSpPr txBox="1"/>
+          <p:nvPr/>
+        </p:nvSpPr>
+        <p:spPr>
+          <a:xfrm>
+            <a:off x="10652760" y="4251960"/>
+            <a:ext cx="1005840" cy="566928"/>
+          </a:xfrm>
+          <a:prstGeom prst="rect">
+            <a:avLst/>
+          </a:prstGeom>
+          <a:noFill/>
+          <a:ln/>
+        </p:spPr>
+        <p:txBody>
+          <a:bodyPr wrap="square" lIns="0" tIns="0" rIns="0" bIns="0" rtlCol="0" anchor="t"/>
+          <a:lstStyle/>
+          <a:p>
+            <a:pPr indent="0" marL="0">
+              <a:buNone/>
+            </a:pPr>
+            <a:r>
+              <a:rPr lang="en-US" sz="800" dirty="0">
+                <a:solidFill>
+                  <a:srgbClr val="475569"/>
+                </a:solidFill>
+                <a:latin typeface="Montserrat" pitchFamily="34" charset="0"/>
+                <a:ea typeface="Montserrat" pitchFamily="34" charset="-122"/>
+                <a:cs typeface="Montserrat" pitchFamily="34" charset="-120"/>
+              </a:rPr>
+              <a:t>Déploiement : 50 puis 100 apprentis</a:t>
+            </a:r>
+            <a:endParaRPr lang="en-US" sz="800" dirty="0"/>
+          </a:p>
+        </p:txBody>
+      </p:sp>
+      <p:sp>
+        <p:nvSpPr>
+          <p:cNvPr id="88" name="Marqueur aujourd'hui"/>
+          <p:cNvSpPr/>
+          <p:nvPr/>
+        </p:nvSpPr>
+        <p:spPr>
+          <a:xfrm flipV="1">
+            <a:off x="6044184" y="3465576"/>
+            <a:ext cx="146304" cy="118872"/>
+          </a:xfrm>
+          <a:prstGeom prst="triangle">
+            <a:avLst/>
+          </a:prstGeom>
+          <a:solidFill>
+            <a:srgbClr val="01A6E0"/>
+          </a:solidFill>
+          <a:ln w="12700">
             <a:solidFill>
               <a:srgbClr val="01A6E0"/>
             </a:solidFill>
@@ -2067,53 +3557,131 @@
       </p:sp>
       <p:sp>
         <p:nvSpPr>
-          <p:cNvPr id="38" name="Date jalon 3"/>
-          <p:cNvSpPr txBox="1"/>
-          <p:nvPr/>
-        </p:nvSpPr>
-        <p:spPr>
-          <a:xfrm>
-            <a:off x="7749540" y="3364992"/>
-            <a:ext cx="1371600" cy="274320"/>
-          </a:xfrm>
-          <a:prstGeom prst="rect">
-            <a:avLst/>
-          </a:prstGeom>
-          <a:noFill/>
-          <a:ln/>
-        </p:spPr>
-        <p:txBody>
-          <a:bodyPr wrap="square" lIns="0" tIns="0" rIns="0" bIns="0" rtlCol="0" anchor="b"/>
-          <a:lstStyle/>
-          <a:p>
-            <a:pPr algn="ctr" indent="0" marL="0">
-              <a:buNone/>
-            </a:pPr>
-            <a:r>
-              <a:rPr lang="en-US" sz="1000" b="1" dirty="0">
-                <a:solidFill>
-                  <a:srgbClr val="152539"/>
-                </a:solidFill>
-                <a:latin typeface="Montserrat" pitchFamily="34" charset="0"/>
-                <a:ea typeface="Montserrat" pitchFamily="34" charset="-122"/>
-                <a:cs typeface="Montserrat" pitchFamily="34" charset="-120"/>
-              </a:rPr>
-              <a:t>Fév. 2027</a:t>
-            </a:r>
-            <a:endParaRPr lang="en-US" sz="1000" dirty="0"/>
-          </a:p>
-        </p:txBody>
-      </p:sp>
-      <p:sp>
-        <p:nvSpPr>
-          <p:cNvPr id="39" name="Texte jalon 3"/>
-          <p:cNvSpPr txBox="1"/>
-          <p:nvPr/>
-        </p:nvSpPr>
-        <p:spPr>
-          <a:xfrm>
-            <a:off x="7749540" y="4187952"/>
-            <a:ext cx="1371600" cy="502920"/>
+          <p:cNvPr id="89" name="Texte aujourd&amp;apos;hui"/>
+          <p:cNvSpPr txBox="1"/>
+          <p:nvPr/>
+        </p:nvSpPr>
+        <p:spPr>
+          <a:xfrm>
+            <a:off x="6227064" y="3410712"/>
+            <a:ext cx="1097280" cy="182880"/>
+          </a:xfrm>
+          <a:prstGeom prst="rect">
+            <a:avLst/>
+          </a:prstGeom>
+          <a:noFill/>
+          <a:ln/>
+        </p:spPr>
+        <p:txBody>
+          <a:bodyPr wrap="square" lIns="0" tIns="0" rIns="0" bIns="0" rtlCol="0" anchor="ctr"/>
+          <a:lstStyle/>
+          <a:p>
+            <a:pPr indent="0" marL="0">
+              <a:buNone/>
+            </a:pPr>
+            <a:r>
+              <a:rPr lang="en-US" sz="750" i="1" dirty="0">
+                <a:solidFill>
+                  <a:srgbClr val="01A6E0"/>
+                </a:solidFill>
+                <a:latin typeface="Montserrat" pitchFamily="34" charset="0"/>
+                <a:ea typeface="Montserrat" pitchFamily="34" charset="-122"/>
+                <a:cs typeface="Montserrat" pitchFamily="34" charset="-120"/>
+              </a:rPr>
+              <a:t>aujourd'hui</a:t>
+            </a:r>
+            <a:endParaRPr lang="en-US" sz="750" dirty="0"/>
+          </a:p>
+        </p:txBody>
+      </p:sp>
+      <p:sp>
+        <p:nvSpPr>
+          <p:cNvPr id="90" name="Label cibles"/>
+          <p:cNvSpPr txBox="1"/>
+          <p:nvPr/>
+        </p:nvSpPr>
+        <p:spPr>
+          <a:xfrm>
+            <a:off x="4617720" y="4956048"/>
+            <a:ext cx="5486400" cy="219456"/>
+          </a:xfrm>
+          <a:prstGeom prst="rect">
+            <a:avLst/>
+          </a:prstGeom>
+          <a:noFill/>
+          <a:ln/>
+        </p:spPr>
+        <p:txBody>
+          <a:bodyPr wrap="square" lIns="0" tIns="0" rIns="0" bIns="0" rtlCol="0" anchor="ctr"/>
+          <a:lstStyle/>
+          <a:p>
+            <a:pPr indent="0" marL="0">
+              <a:buNone/>
+            </a:pPr>
+            <a:r>
+              <a:rPr lang="en-US" sz="900" b="1" spc="250" kern="0" dirty="0">
+                <a:solidFill>
+                  <a:srgbClr val="01A6E0"/>
+                </a:solidFill>
+                <a:latin typeface="Montserrat" pitchFamily="34" charset="0"/>
+                <a:ea typeface="Montserrat" pitchFamily="34" charset="-122"/>
+                <a:cs typeface="Montserrat" pitchFamily="34" charset="-120"/>
+              </a:rPr>
+              <a:t>CIBLES DU MVP  ·  NOV. 2026 → JANV. 2027</a:t>
+            </a:r>
+            <a:endParaRPr lang="en-US" sz="900" dirty="0"/>
+          </a:p>
+        </p:txBody>
+      </p:sp>
+      <p:sp>
+        <p:nvSpPr>
+          <p:cNvPr id="91" name="Cible 1"/>
+          <p:cNvSpPr txBox="1"/>
+          <p:nvPr/>
+        </p:nvSpPr>
+        <p:spPr>
+          <a:xfrm>
+            <a:off x="4617720" y="5230368"/>
+            <a:ext cx="1691640" cy="411480"/>
+          </a:xfrm>
+          <a:prstGeom prst="rect">
+            <a:avLst/>
+          </a:prstGeom>
+          <a:noFill/>
+          <a:ln/>
+        </p:spPr>
+        <p:txBody>
+          <a:bodyPr wrap="square" lIns="0" tIns="0" rIns="0" bIns="0" rtlCol="0" anchor="ctr"/>
+          <a:lstStyle/>
+          <a:p>
+            <a:pPr indent="0" marL="0">
+              <a:buNone/>
+            </a:pPr>
+            <a:r>
+              <a:rPr lang="en-US" sz="2200" b="1" dirty="0">
+                <a:solidFill>
+                  <a:srgbClr val="01A6E0"/>
+                </a:solidFill>
+                <a:latin typeface="Montserrat" pitchFamily="34" charset="0"/>
+                <a:ea typeface="Montserrat" pitchFamily="34" charset="-122"/>
+                <a:cs typeface="Montserrat" pitchFamily="34" charset="-120"/>
+              </a:rPr>
+              <a:t>100 %</a:t>
+            </a:r>
+            <a:endParaRPr lang="en-US" sz="2200" dirty="0"/>
+          </a:p>
+        </p:txBody>
+      </p:sp>
+      <p:sp>
+        <p:nvSpPr>
+          <p:cNvPr id="92" name="Cible libellé 1"/>
+          <p:cNvSpPr txBox="1"/>
+          <p:nvPr/>
+        </p:nvSpPr>
+        <p:spPr>
+          <a:xfrm>
+            <a:off x="4617720" y="5669280"/>
+            <a:ext cx="1691640" cy="438912"/>
           </a:xfrm>
           <a:prstGeom prst="rect">
             <a:avLst/>
@@ -2125,7 +3693,7 @@
           <a:bodyPr wrap="square" lIns="0" tIns="0" rIns="0" bIns="0" rtlCol="0" anchor="t"/>
           <a:lstStyle/>
           <a:p>
-            <a:pPr algn="ctr" indent="0" marL="0">
+            <a:pPr indent="0" marL="0">
               <a:buNone/>
             </a:pPr>
             <a:r>
@@ -2137,7 +3705,7 @@
                 <a:ea typeface="Montserrat" pitchFamily="34" charset="-122"/>
                 <a:cs typeface="Montserrat" pitchFamily="34" charset="-120"/>
               </a:rPr>
-              <a:t>Pilote élargi, ≥ 25 apprentis Atlas</a:t>
+              <a:t>de la classe pilote connectée dès la première séance</a:t>
             </a:r>
             <a:endParaRPr lang="en-US" sz="850" dirty="0"/>
           </a:p>
@@ -2145,78 +3713,53 @@
       </p:sp>
       <p:sp>
         <p:nvSpPr>
-          <p:cNvPr id="40" name="Jalon 4"/>
-          <p:cNvSpPr/>
-          <p:nvPr/>
-        </p:nvSpPr>
-        <p:spPr>
-          <a:xfrm>
-            <a:off x="9772650" y="3840480"/>
-            <a:ext cx="182880" cy="182880"/>
-          </a:xfrm>
-          <a:prstGeom prst="ellipse">
-            <a:avLst/>
-          </a:prstGeom>
-          <a:solidFill>
-            <a:srgbClr val="FFFFFF"/>
-          </a:solidFill>
-          <a:ln w="19050">
-            <a:solidFill>
-              <a:srgbClr val="01A6E0"/>
-            </a:solidFill>
-            <a:prstDash val="solid"/>
-          </a:ln>
-        </p:spPr>
-      </p:sp>
-      <p:sp>
-        <p:nvSpPr>
-          <p:cNvPr id="41" name="Date jalon 4"/>
-          <p:cNvSpPr txBox="1"/>
-          <p:nvPr/>
-        </p:nvSpPr>
-        <p:spPr>
-          <a:xfrm>
-            <a:off x="9178290" y="3364992"/>
-            <a:ext cx="1371600" cy="274320"/>
-          </a:xfrm>
-          <a:prstGeom prst="rect">
-            <a:avLst/>
-          </a:prstGeom>
-          <a:noFill/>
-          <a:ln/>
-        </p:spPr>
-        <p:txBody>
-          <a:bodyPr wrap="square" lIns="0" tIns="0" rIns="0" bIns="0" rtlCol="0" anchor="b"/>
-          <a:lstStyle/>
-          <a:p>
-            <a:pPr algn="ctr" indent="0" marL="0">
-              <a:buNone/>
-            </a:pPr>
-            <a:r>
-              <a:rPr lang="en-US" sz="1000" b="1" dirty="0">
-                <a:solidFill>
-                  <a:srgbClr val="152539"/>
-                </a:solidFill>
-                <a:latin typeface="Montserrat" pitchFamily="34" charset="0"/>
-                <a:ea typeface="Montserrat" pitchFamily="34" charset="-122"/>
-                <a:cs typeface="Montserrat" pitchFamily="34" charset="-120"/>
-              </a:rPr>
-              <a:t>Juin 2027</a:t>
-            </a:r>
-            <a:endParaRPr lang="en-US" sz="1000" dirty="0"/>
-          </a:p>
-        </p:txBody>
-      </p:sp>
-      <p:sp>
-        <p:nvSpPr>
-          <p:cNvPr id="42" name="Texte jalon 4"/>
-          <p:cNvSpPr txBox="1"/>
-          <p:nvPr/>
-        </p:nvSpPr>
-        <p:spPr>
-          <a:xfrm>
-            <a:off x="9178290" y="4187952"/>
-            <a:ext cx="1371600" cy="502920"/>
+          <p:cNvPr id="93" name="Cible 2"/>
+          <p:cNvSpPr txBox="1"/>
+          <p:nvPr/>
+        </p:nvSpPr>
+        <p:spPr>
+          <a:xfrm>
+            <a:off x="6446520" y="5230368"/>
+            <a:ext cx="1691640" cy="411480"/>
+          </a:xfrm>
+          <a:prstGeom prst="rect">
+            <a:avLst/>
+          </a:prstGeom>
+          <a:noFill/>
+          <a:ln/>
+        </p:spPr>
+        <p:txBody>
+          <a:bodyPr wrap="square" lIns="0" tIns="0" rIns="0" bIns="0" rtlCol="0" anchor="ctr"/>
+          <a:lstStyle/>
+          <a:p>
+            <a:pPr indent="0" marL="0">
+              <a:buNone/>
+            </a:pPr>
+            <a:r>
+              <a:rPr lang="en-US" sz="2200" b="1" dirty="0">
+                <a:solidFill>
+                  <a:srgbClr val="01A6E0"/>
+                </a:solidFill>
+                <a:latin typeface="Montserrat" pitchFamily="34" charset="0"/>
+                <a:ea typeface="Montserrat" pitchFamily="34" charset="-122"/>
+                <a:cs typeface="Montserrat" pitchFamily="34" charset="-120"/>
+              </a:rPr>
+              <a:t>2+ / sem.</a:t>
+            </a:r>
+            <a:endParaRPr lang="en-US" sz="2200" dirty="0"/>
+          </a:p>
+        </p:txBody>
+      </p:sp>
+      <p:sp>
+        <p:nvSpPr>
+          <p:cNvPr id="94" name="Cible libellé 2"/>
+          <p:cNvSpPr txBox="1"/>
+          <p:nvPr/>
+        </p:nvSpPr>
+        <p:spPr>
+          <a:xfrm>
+            <a:off x="6446520" y="5669280"/>
+            <a:ext cx="1691640" cy="438912"/>
           </a:xfrm>
           <a:prstGeom prst="rect">
             <a:avLst/>
@@ -2228,7 +3771,7 @@
           <a:bodyPr wrap="square" lIns="0" tIns="0" rIns="0" bIns="0" rtlCol="0" anchor="t"/>
           <a:lstStyle/>
           <a:p>
-            <a:pPr algn="ctr" indent="0" marL="0">
+            <a:pPr indent="0" marL="0">
               <a:buNone/>
             </a:pPr>
             <a:r>
@@ -2240,7 +3783,7 @@
                 <a:ea typeface="Montserrat" pitchFamily="34" charset="-122"/>
                 <a:cs typeface="Montserrat" pitchFamily="34" charset="-120"/>
               </a:rPr>
-              <a:t>Point mi-parcours Atlas, retours tuteurs</a:t>
+              <a:t>sessions par apprenti, en classe et en autonomie</a:t>
             </a:r>
             <a:endParaRPr lang="en-US" sz="850" dirty="0"/>
           </a:p>
@@ -2248,78 +3791,53 @@
       </p:sp>
       <p:sp>
         <p:nvSpPr>
-          <p:cNvPr id="43" name="Jalon 5"/>
-          <p:cNvSpPr/>
-          <p:nvPr/>
-        </p:nvSpPr>
-        <p:spPr>
-          <a:xfrm>
-            <a:off x="11201400" y="3840480"/>
-            <a:ext cx="182880" cy="182880"/>
-          </a:xfrm>
-          <a:prstGeom prst="ellipse">
-            <a:avLst/>
-          </a:prstGeom>
-          <a:solidFill>
-            <a:srgbClr val="FFFFFF"/>
-          </a:solidFill>
-          <a:ln w="19050">
-            <a:solidFill>
-              <a:srgbClr val="01A6E0"/>
-            </a:solidFill>
-            <a:prstDash val="solid"/>
-          </a:ln>
-        </p:spPr>
-      </p:sp>
-      <p:sp>
-        <p:nvSpPr>
-          <p:cNvPr id="44" name="Date jalon 5"/>
-          <p:cNvSpPr txBox="1"/>
-          <p:nvPr/>
-        </p:nvSpPr>
-        <p:spPr>
-          <a:xfrm>
-            <a:off x="10607040" y="3364992"/>
-            <a:ext cx="1371600" cy="274320"/>
-          </a:xfrm>
-          <a:prstGeom prst="rect">
-            <a:avLst/>
-          </a:prstGeom>
-          <a:noFill/>
-          <a:ln/>
-        </p:spPr>
-        <p:txBody>
-          <a:bodyPr wrap="square" lIns="0" tIns="0" rIns="0" bIns="0" rtlCol="0" anchor="b"/>
-          <a:lstStyle/>
-          <a:p>
-            <a:pPr algn="ctr" indent="0" marL="0">
-              <a:buNone/>
-            </a:pPr>
-            <a:r>
-              <a:rPr lang="en-US" sz="1000" b="1" dirty="0">
-                <a:solidFill>
-                  <a:srgbClr val="152539"/>
-                </a:solidFill>
-                <a:latin typeface="Montserrat" pitchFamily="34" charset="0"/>
-                <a:ea typeface="Montserrat" pitchFamily="34" charset="-122"/>
-                <a:cs typeface="Montserrat" pitchFamily="34" charset="-120"/>
-              </a:rPr>
-              <a:t>Oct. 2027</a:t>
-            </a:r>
-            <a:endParaRPr lang="en-US" sz="1000" dirty="0"/>
-          </a:p>
-        </p:txBody>
-      </p:sp>
-      <p:sp>
-        <p:nvSpPr>
-          <p:cNvPr id="45" name="Texte jalon 5"/>
-          <p:cNvSpPr txBox="1"/>
-          <p:nvPr/>
-        </p:nvSpPr>
-        <p:spPr>
-          <a:xfrm>
-            <a:off x="10607040" y="4187952"/>
-            <a:ext cx="1371600" cy="502920"/>
+          <p:cNvPr id="95" name="Cible 3"/>
+          <p:cNvSpPr txBox="1"/>
+          <p:nvPr/>
+        </p:nvSpPr>
+        <p:spPr>
+          <a:xfrm>
+            <a:off x="8275320" y="5230368"/>
+            <a:ext cx="1691640" cy="411480"/>
+          </a:xfrm>
+          <a:prstGeom prst="rect">
+            <a:avLst/>
+          </a:prstGeom>
+          <a:noFill/>
+          <a:ln/>
+        </p:spPr>
+        <p:txBody>
+          <a:bodyPr wrap="square" lIns="0" tIns="0" rIns="0" bIns="0" rtlCol="0" anchor="ctr"/>
+          <a:lstStyle/>
+          <a:p>
+            <a:pPr indent="0" marL="0">
+              <a:buNone/>
+            </a:pPr>
+            <a:r>
+              <a:rPr lang="en-US" sz="2200" b="1" dirty="0">
+                <a:solidFill>
+                  <a:srgbClr val="01A6E0"/>
+                </a:solidFill>
+                <a:latin typeface="Montserrat" pitchFamily="34" charset="0"/>
+                <a:ea typeface="Montserrat" pitchFamily="34" charset="-122"/>
+                <a:cs typeface="Montserrat" pitchFamily="34" charset="-120"/>
+              </a:rPr>
+              <a:t>80 %+</a:t>
+            </a:r>
+            <a:endParaRPr lang="en-US" sz="2200" dirty="0"/>
+          </a:p>
+        </p:txBody>
+      </p:sp>
+      <p:sp>
+        <p:nvSpPr>
+          <p:cNvPr id="96" name="Cible libellé 3"/>
+          <p:cNvSpPr txBox="1"/>
+          <p:nvPr/>
+        </p:nvSpPr>
+        <p:spPr>
+          <a:xfrm>
+            <a:off x="8275320" y="5669280"/>
+            <a:ext cx="1691640" cy="438912"/>
           </a:xfrm>
           <a:prstGeom prst="rect">
             <a:avLst/>
@@ -2331,7 +3849,7 @@
           <a:bodyPr wrap="square" lIns="0" tIns="0" rIns="0" bIns="0" rtlCol="0" anchor="t"/>
           <a:lstStyle/>
           <a:p>
-            <a:pPr algn="ctr" indent="0" marL="0">
+            <a:pPr indent="0" marL="0">
               <a:buNone/>
             </a:pPr>
             <a:r>
@@ -2343,7 +3861,7 @@
                 <a:ea typeface="Montserrat" pitchFamily="34" charset="-122"/>
                 <a:cs typeface="Montserrat" pitchFamily="34" charset="-120"/>
               </a:rPr>
-              <a:t>Déploiement : 50 puis 100 apprentis</a:t>
+              <a:t>des deux scénarios terminés et soumis</a:t>
             </a:r>
             <a:endParaRPr lang="en-US" sz="850" dirty="0"/>
           </a:p>
@@ -2351,14 +3869,14 @@
       </p:sp>
       <p:sp>
         <p:nvSpPr>
-          <p:cNvPr id="46" name="Label cibles"/>
-          <p:cNvSpPr txBox="1"/>
-          <p:nvPr/>
-        </p:nvSpPr>
-        <p:spPr>
-          <a:xfrm>
-            <a:off x="5074920" y="4892040"/>
-            <a:ext cx="6720840" cy="237744"/>
+          <p:cNvPr id="97" name="Cible 4"/>
+          <p:cNvSpPr txBox="1"/>
+          <p:nvPr/>
+        </p:nvSpPr>
+        <p:spPr>
+          <a:xfrm>
+            <a:off x="10104120" y="5230368"/>
+            <a:ext cx="1691640" cy="411480"/>
           </a:xfrm>
           <a:prstGeom prst="rect">
             <a:avLst/>
@@ -2374,7 +3892,7 @@
               <a:buNone/>
             </a:pPr>
             <a:r>
-              <a:rPr lang="en-US" sz="900" b="1" spc="250" kern="0" dirty="0">
+              <a:rPr lang="en-US" sz="2200" b="1" dirty="0">
                 <a:solidFill>
                   <a:srgbClr val="01A6E0"/>
                 </a:solidFill>
@@ -2382,77 +3900,38 @@
                 <a:ea typeface="Montserrat" pitchFamily="34" charset="-122"/>
                 <a:cs typeface="Montserrat" pitchFamily="34" charset="-120"/>
               </a:rPr>
-              <a:t>CIBLES DU MVP  ·  NOV. 2026 → JANV. 2027</a:t>
-            </a:r>
-            <a:endParaRPr lang="en-US" sz="900" dirty="0"/>
-          </a:p>
-        </p:txBody>
-      </p:sp>
-      <p:sp>
-        <p:nvSpPr>
-          <p:cNvPr id="47" name="Cible 1"/>
-          <p:cNvSpPr txBox="1"/>
-          <p:nvPr/>
-        </p:nvSpPr>
-        <p:spPr>
-          <a:xfrm>
-            <a:off x="5074920" y="5212080"/>
-            <a:ext cx="1627632" cy="457200"/>
-          </a:xfrm>
-          <a:prstGeom prst="rect">
-            <a:avLst/>
-          </a:prstGeom>
-          <a:noFill/>
-          <a:ln/>
-        </p:spPr>
-        <p:txBody>
-          <a:bodyPr wrap="square" lIns="0" tIns="0" rIns="0" bIns="0" rtlCol="0" anchor="ctr"/>
+              <a:t>&lt; 1 min</a:t>
+            </a:r>
+            <a:endParaRPr lang="en-US" sz="2200" dirty="0"/>
+          </a:p>
+        </p:txBody>
+      </p:sp>
+      <p:sp>
+        <p:nvSpPr>
+          <p:cNvPr id="98" name="Cible libellé 4"/>
+          <p:cNvSpPr txBox="1"/>
+          <p:nvPr/>
+        </p:nvSpPr>
+        <p:spPr>
+          <a:xfrm>
+            <a:off x="10104120" y="5669280"/>
+            <a:ext cx="1691640" cy="438912"/>
+          </a:xfrm>
+          <a:prstGeom prst="rect">
+            <a:avLst/>
+          </a:prstGeom>
+          <a:noFill/>
+          <a:ln/>
+        </p:spPr>
+        <p:txBody>
+          <a:bodyPr wrap="square" lIns="0" tIns="0" rIns="0" bIns="0" rtlCol="0" anchor="t"/>
           <a:lstStyle/>
           <a:p>
             <a:pPr indent="0" marL="0">
               <a:buNone/>
             </a:pPr>
             <a:r>
-              <a:rPr lang="en-US" sz="2400" b="1" dirty="0">
-                <a:solidFill>
-                  <a:srgbClr val="01A6E0"/>
-                </a:solidFill>
-                <a:latin typeface="Montserrat" pitchFamily="34" charset="0"/>
-                <a:ea typeface="Montserrat" pitchFamily="34" charset="-122"/>
-                <a:cs typeface="Montserrat" pitchFamily="34" charset="-120"/>
-              </a:rPr>
-              <a:t>100 %</a:t>
-            </a:r>
-            <a:endParaRPr lang="en-US" sz="2400" dirty="0"/>
-          </a:p>
-        </p:txBody>
-      </p:sp>
-      <p:sp>
-        <p:nvSpPr>
-          <p:cNvPr id="48" name="Cible libellé 1"/>
-          <p:cNvSpPr txBox="1"/>
-          <p:nvPr/>
-        </p:nvSpPr>
-        <p:spPr>
-          <a:xfrm>
-            <a:off x="5074920" y="5687568"/>
-            <a:ext cx="1627632" cy="457200"/>
-          </a:xfrm>
-          <a:prstGeom prst="rect">
-            <a:avLst/>
-          </a:prstGeom>
-          <a:noFill/>
-          <a:ln/>
-        </p:spPr>
-        <p:txBody>
-          <a:bodyPr wrap="square" lIns="0" tIns="0" rIns="0" bIns="0" rtlCol="0" anchor="t"/>
-          <a:lstStyle/>
-          <a:p>
-            <a:pPr indent="0" marL="0">
-              <a:buNone/>
-            </a:pPr>
-            <a:r>
-              <a:rPr lang="en-US" sz="900" dirty="0">
+              <a:rPr lang="en-US" sz="850" dirty="0">
                 <a:solidFill>
                   <a:srgbClr val="475569"/>
                 </a:solidFill>
@@ -2460,256 +3939,22 @@
                 <a:ea typeface="Montserrat" pitchFamily="34" charset="-122"/>
                 <a:cs typeface="Montserrat" pitchFamily="34" charset="-120"/>
               </a:rPr>
-              <a:t>de la classe pilote connectée dès la première séance</a:t>
-            </a:r>
-            <a:endParaRPr lang="en-US" sz="900" dirty="0"/>
-          </a:p>
-        </p:txBody>
-      </p:sp>
-      <p:sp>
-        <p:nvSpPr>
-          <p:cNvPr id="49" name="Cible 2"/>
-          <p:cNvSpPr txBox="1"/>
-          <p:nvPr/>
-        </p:nvSpPr>
-        <p:spPr>
-          <a:xfrm>
-            <a:off x="6772656" y="5212080"/>
-            <a:ext cx="1627632" cy="457200"/>
-          </a:xfrm>
-          <a:prstGeom prst="rect">
-            <a:avLst/>
-          </a:prstGeom>
-          <a:noFill/>
-          <a:ln/>
-        </p:spPr>
-        <p:txBody>
-          <a:bodyPr wrap="square" lIns="0" tIns="0" rIns="0" bIns="0" rtlCol="0" anchor="ctr"/>
-          <a:lstStyle/>
-          <a:p>
-            <a:pPr indent="0" marL="0">
-              <a:buNone/>
-            </a:pPr>
-            <a:r>
-              <a:rPr lang="en-US" sz="2400" b="1" dirty="0">
-                <a:solidFill>
-                  <a:srgbClr val="01A6E0"/>
-                </a:solidFill>
-                <a:latin typeface="Montserrat" pitchFamily="34" charset="0"/>
-                <a:ea typeface="Montserrat" pitchFamily="34" charset="-122"/>
-                <a:cs typeface="Montserrat" pitchFamily="34" charset="-120"/>
-              </a:rPr>
-              <a:t>2+ / sem.</a:t>
-            </a:r>
-            <a:endParaRPr lang="en-US" sz="2400" dirty="0"/>
-          </a:p>
-        </p:txBody>
-      </p:sp>
-      <p:sp>
-        <p:nvSpPr>
-          <p:cNvPr id="50" name="Cible libellé 2"/>
-          <p:cNvSpPr txBox="1"/>
-          <p:nvPr/>
-        </p:nvSpPr>
-        <p:spPr>
-          <a:xfrm>
-            <a:off x="6772656" y="5687568"/>
-            <a:ext cx="1627632" cy="457200"/>
-          </a:xfrm>
-          <a:prstGeom prst="rect">
-            <a:avLst/>
-          </a:prstGeom>
-          <a:noFill/>
-          <a:ln/>
-        </p:spPr>
-        <p:txBody>
-          <a:bodyPr wrap="square" lIns="0" tIns="0" rIns="0" bIns="0" rtlCol="0" anchor="t"/>
-          <a:lstStyle/>
-          <a:p>
-            <a:pPr indent="0" marL="0">
-              <a:buNone/>
-            </a:pPr>
-            <a:r>
-              <a:rPr lang="en-US" sz="900" dirty="0">
-                <a:solidFill>
-                  <a:srgbClr val="475569"/>
-                </a:solidFill>
-                <a:latin typeface="Montserrat" pitchFamily="34" charset="0"/>
-                <a:ea typeface="Montserrat" pitchFamily="34" charset="-122"/>
-                <a:cs typeface="Montserrat" pitchFamily="34" charset="-120"/>
-              </a:rPr>
-              <a:t>sessions par apprenti, en classe et en autonomie</a:t>
-            </a:r>
-            <a:endParaRPr lang="en-US" sz="900" dirty="0"/>
-          </a:p>
-        </p:txBody>
-      </p:sp>
-      <p:sp>
-        <p:nvSpPr>
-          <p:cNvPr id="51" name="Cible 3"/>
-          <p:cNvSpPr txBox="1"/>
-          <p:nvPr/>
-        </p:nvSpPr>
-        <p:spPr>
-          <a:xfrm>
-            <a:off x="8470392" y="5212080"/>
-            <a:ext cx="1627632" cy="457200"/>
-          </a:xfrm>
-          <a:prstGeom prst="rect">
-            <a:avLst/>
-          </a:prstGeom>
-          <a:noFill/>
-          <a:ln/>
-        </p:spPr>
-        <p:txBody>
-          <a:bodyPr wrap="square" lIns="0" tIns="0" rIns="0" bIns="0" rtlCol="0" anchor="ctr"/>
-          <a:lstStyle/>
-          <a:p>
-            <a:pPr indent="0" marL="0">
-              <a:buNone/>
-            </a:pPr>
-            <a:r>
-              <a:rPr lang="en-US" sz="2400" b="1" dirty="0">
-                <a:solidFill>
-                  <a:srgbClr val="01A6E0"/>
-                </a:solidFill>
-                <a:latin typeface="Montserrat" pitchFamily="34" charset="0"/>
-                <a:ea typeface="Montserrat" pitchFamily="34" charset="-122"/>
-                <a:cs typeface="Montserrat" pitchFamily="34" charset="-120"/>
-              </a:rPr>
-              <a:t>≥ 80 %</a:t>
-            </a:r>
-            <a:endParaRPr lang="en-US" sz="2400" dirty="0"/>
-          </a:p>
-        </p:txBody>
-      </p:sp>
-      <p:sp>
-        <p:nvSpPr>
-          <p:cNvPr id="52" name="Cible libellé 3"/>
-          <p:cNvSpPr txBox="1"/>
-          <p:nvPr/>
-        </p:nvSpPr>
-        <p:spPr>
-          <a:xfrm>
-            <a:off x="8470392" y="5687568"/>
-            <a:ext cx="1627632" cy="457200"/>
-          </a:xfrm>
-          <a:prstGeom prst="rect">
-            <a:avLst/>
-          </a:prstGeom>
-          <a:noFill/>
-          <a:ln/>
-        </p:spPr>
-        <p:txBody>
-          <a:bodyPr wrap="square" lIns="0" tIns="0" rIns="0" bIns="0" rtlCol="0" anchor="t"/>
-          <a:lstStyle/>
-          <a:p>
-            <a:pPr indent="0" marL="0">
-              <a:buNone/>
-            </a:pPr>
-            <a:r>
-              <a:rPr lang="en-US" sz="900" dirty="0">
-                <a:solidFill>
-                  <a:srgbClr val="475569"/>
-                </a:solidFill>
-                <a:latin typeface="Montserrat" pitchFamily="34" charset="0"/>
-                <a:ea typeface="Montserrat" pitchFamily="34" charset="-122"/>
-                <a:cs typeface="Montserrat" pitchFamily="34" charset="-120"/>
-              </a:rPr>
-              <a:t>des deux scénarios terminés et soumis</a:t>
-            </a:r>
-            <a:endParaRPr lang="en-US" sz="900" dirty="0"/>
-          </a:p>
-        </p:txBody>
-      </p:sp>
-      <p:sp>
-        <p:nvSpPr>
-          <p:cNvPr id="53" name="Cible 4"/>
-          <p:cNvSpPr txBox="1"/>
-          <p:nvPr/>
-        </p:nvSpPr>
-        <p:spPr>
-          <a:xfrm>
-            <a:off x="10168128" y="5212080"/>
-            <a:ext cx="1627632" cy="457200"/>
-          </a:xfrm>
-          <a:prstGeom prst="rect">
-            <a:avLst/>
-          </a:prstGeom>
-          <a:noFill/>
-          <a:ln/>
-        </p:spPr>
-        <p:txBody>
-          <a:bodyPr wrap="square" lIns="0" tIns="0" rIns="0" bIns="0" rtlCol="0" anchor="ctr"/>
-          <a:lstStyle/>
-          <a:p>
-            <a:pPr indent="0" marL="0">
-              <a:buNone/>
-            </a:pPr>
-            <a:r>
-              <a:rPr lang="en-US" sz="2400" b="1" dirty="0">
-                <a:solidFill>
-                  <a:srgbClr val="01A6E0"/>
-                </a:solidFill>
-                <a:latin typeface="Montserrat" pitchFamily="34" charset="0"/>
-                <a:ea typeface="Montserrat" pitchFamily="34" charset="-122"/>
-                <a:cs typeface="Montserrat" pitchFamily="34" charset="-120"/>
-              </a:rPr>
-              <a:t>&lt; 1 min</a:t>
-            </a:r>
-            <a:endParaRPr lang="en-US" sz="2400" dirty="0"/>
-          </a:p>
-        </p:txBody>
-      </p:sp>
-      <p:sp>
-        <p:nvSpPr>
-          <p:cNvPr id="54" name="Cible libellé 4"/>
-          <p:cNvSpPr txBox="1"/>
-          <p:nvPr/>
-        </p:nvSpPr>
-        <p:spPr>
-          <a:xfrm>
-            <a:off x="10168128" y="5687568"/>
-            <a:ext cx="1627632" cy="457200"/>
-          </a:xfrm>
-          <a:prstGeom prst="rect">
-            <a:avLst/>
-          </a:prstGeom>
-          <a:noFill/>
-          <a:ln/>
-        </p:spPr>
-        <p:txBody>
-          <a:bodyPr wrap="square" lIns="0" tIns="0" rIns="0" bIns="0" rtlCol="0" anchor="t"/>
-          <a:lstStyle/>
-          <a:p>
-            <a:pPr indent="0" marL="0">
-              <a:buNone/>
-            </a:pPr>
-            <a:r>
-              <a:rPr lang="en-US" sz="900" dirty="0">
-                <a:solidFill>
-                  <a:srgbClr val="475569"/>
-                </a:solidFill>
-                <a:latin typeface="Montserrat" pitchFamily="34" charset="0"/>
-                <a:ea typeface="Montserrat" pitchFamily="34" charset="-122"/>
-                <a:cs typeface="Montserrat" pitchFamily="34" charset="-120"/>
-              </a:rPr>
-              <a:t>de feedback du tuteur IA, concordant avec l'enseignant</a:t>
-            </a:r>
-            <a:endParaRPr lang="en-US" sz="900" dirty="0"/>
-          </a:p>
-        </p:txBody>
-      </p:sp>
-      <p:sp>
-        <p:nvSpPr>
-          <p:cNvPr id="55" name="Sources"/>
-          <p:cNvSpPr txBox="1"/>
-          <p:nvPr/>
-        </p:nvSpPr>
-        <p:spPr>
-          <a:xfrm>
-            <a:off x="5074920" y="6382512"/>
-            <a:ext cx="6720840" cy="292608"/>
+              <a:t>de feedback IA, concordant avec l'enseignant</a:t>
+            </a:r>
+            <a:endParaRPr lang="en-US" sz="850" dirty="0"/>
+          </a:p>
+        </p:txBody>
+      </p:sp>
+      <p:sp>
+        <p:nvSpPr>
+          <p:cNvPr id="99" name="Sources"/>
+          <p:cNvSpPr txBox="1"/>
+          <p:nvPr/>
+        </p:nvSpPr>
+        <p:spPr>
+          <a:xfrm>
+            <a:off x="4617720" y="6355080"/>
+            <a:ext cx="7223760" cy="292608"/>
           </a:xfrm>
           <a:prstGeom prst="rect">
             <a:avLst/>
@@ -2912,7 +4157,7 @@
         <a:srgbClr val="475569"/>
       </a:dk2>
       <a:lt2>
-        <a:srgbClr val="F3F6FA"/>
+        <a:srgbClr val="EAF7FD"/>
       </a:lt2>
       <a:accent1>
         <a:srgbClr val="01A6E0"/>

</xml_diff>